<commit_message>
feat(v7.4.4-7): Mein-Status aufgeraeumt, Hilfe-Dropdown, BerichtePage umstrukturiert, Foerderbetrag-Fix
</commit_message>
<xml_diff>
--- a/docs/UI Update 20260427.pptx
+++ b/docs/UI Update 20260427.pptx
@@ -6,6 +6,9 @@
   </p:sldMasterIdLst>
   <p:sldIdLst>
     <p:sldId id="256" r:id="rId2"/>
+    <p:sldId id="257" r:id="rId3"/>
+    <p:sldId id="258" r:id="rId4"/>
+    <p:sldId id="259" r:id="rId5"/>
   </p:sldIdLst>
   <p:sldSz cx="12192000" cy="6858000"/>
   <p:notesSz cx="6858000" cy="9144000"/>
@@ -105,6 +108,482 @@
     </a:lvl9pPr>
   </p:defaultTextStyle>
 </p:presentation>
+</file>
+
+<file path=ppt/ink/ink1.xml><?xml version="1.0" encoding="utf-8"?>
+<inkml:ink xmlns:inkml="http://www.w3.org/2003/InkML">
+  <inkml:definitions>
+    <inkml:context xml:id="ctx0">
+      <inkml:inkSource xml:id="inkSrc0">
+        <inkml:traceFormat>
+          <inkml:channel name="X" type="integer" min="-2.14748E9" max="2.14748E9" units="cm"/>
+          <inkml:channel name="Y" type="integer" min="-2.14748E9" max="2.14748E9" units="cm"/>
+          <inkml:channel name="F" type="integer" max="32767" units="dev"/>
+        </inkml:traceFormat>
+        <inkml:channelProperties>
+          <inkml:channelProperty channel="X" name="resolution" value="1000" units="1/cm"/>
+          <inkml:channelProperty channel="Y" name="resolution" value="1000" units="1/cm"/>
+          <inkml:channelProperty channel="F" name="resolution" value="0" units="1/dev"/>
+        </inkml:channelProperties>
+      </inkml:inkSource>
+      <inkml:timestamp xml:id="ts0" timeString="2026-04-27T07:19:51.613"/>
+    </inkml:context>
+    <inkml:brush xml:id="br0">
+      <inkml:brushProperty name="width" value="0.035" units="cm"/>
+      <inkml:brushProperty name="height" value="0.035" units="cm"/>
+      <inkml:brushProperty name="color" value="#E71224"/>
+    </inkml:brush>
+  </inkml:definitions>
+  <inkml:trace contextRef="#ctx0" brushRef="#br0">3497 483 24575,'-2'-7'0,"-4"-13"0,-6-4 0,-21-23 0,-25-2 0,-25-4 0,22 24 0,-7 2 0,-16 3 0,-3 2 0,7 0 0,-1 2 0,-18 1 0,1 3 0,27 4 0,2 2 0,-7 1 0,-1 1 0,2 0 0,2 2 0,6 1 0,1 0 0,-8 0 0,0-1 0,9 1 0,2 1 0,7-1 0,0 2 0,-4 0 0,1 0 0,6 0 0,0 1 0,-7 1 0,-3 1 0,-13 0 0,-2-1 0,8 1 0,0 1 0,-10 1 0,0 0 0,10 0 0,2 1 0,10 0 0,3 0 0,-2 0 0,5 0 0,-10 3 0,7 2 0,23 2 0,7 1 0,-2 2 0,-9 4 0,-4-2 0,-11 5 0,0-2 0,10 0 0,4 0 0,16 1 0,3 11 0,5 17 0,6 10 0,3 10 0,4-3 0,2-11 0,1 2 0,7-9 0,11 20 0,12 0 0,12 9 0,12-5 0,7-5 0,2-10 0,13-3 0,0-13 0,5-7 0,-35-19 0,0-2 0,37 3 0,-37-8 0,1-1 0,48 2 0,-4 0 0,-37-1 0,2 1 0,1 2 0,1 2 0,-3-1 0,3 0 0,17 2 0,1-2 0,-19-4 0,0-2 0,8-1 0,0-1 0,-8-3 0,-3-2 0,31-7 0,-40 0 0,1-2 0,0-4 0,-2 0 0,40-17 0,-38 16 0,-2 2 0,24-6 0,-9 6 0,-7-2 0,-13-1 0,2-9 0,-5-4 0,-3 0 0,5-6 0,-5 9 0,1-1 0,0 4 0,-13 9 0,4-6 0,1-3 0,3-3 0,1-3 0,-6 7 0,-7 3 0,-4 2 0,-1-1 0,3-1 0,0-1 0,-1 1 0,2 0 0,1-3 0,-3 5 0,-1 0 0,-8 9 0,-3 3 0,-3-7 0,-1-7 0,0-5 0,-1 1 0,-10 7 0,-29 3 0,-24 6 0,16 0 0,2 9 0</inkml:trace>
+</inkml:ink>
+</file>
+
+<file path=ppt/ink/ink10.xml><?xml version="1.0" encoding="utf-8"?>
+<inkml:ink xmlns:inkml="http://www.w3.org/2003/InkML">
+  <inkml:definitions>
+    <inkml:context xml:id="ctx0">
+      <inkml:inkSource xml:id="inkSrc0">
+        <inkml:traceFormat>
+          <inkml:channel name="X" type="integer" min="-2.14748E9" max="2.14748E9" units="cm"/>
+          <inkml:channel name="Y" type="integer" min="-2.14748E9" max="2.14748E9" units="cm"/>
+          <inkml:channel name="F" type="integer" max="32767" units="dev"/>
+        </inkml:traceFormat>
+        <inkml:channelProperties>
+          <inkml:channelProperty channel="X" name="resolution" value="1000" units="1/cm"/>
+          <inkml:channelProperty channel="Y" name="resolution" value="1000" units="1/cm"/>
+          <inkml:channelProperty channel="F" name="resolution" value="0" units="1/dev"/>
+        </inkml:channelProperties>
+      </inkml:inkSource>
+      <inkml:timestamp xml:id="ts0" timeString="2026-04-27T07:20:43.869"/>
+    </inkml:context>
+    <inkml:brush xml:id="br0">
+      <inkml:brushProperty name="width" value="0.035" units="cm"/>
+      <inkml:brushProperty name="height" value="0.035" units="cm"/>
+      <inkml:brushProperty name="color" value="#E71224"/>
+    </inkml:brush>
+  </inkml:definitions>
+  <inkml:trace contextRef="#ctx0" brushRef="#br0">1 0 24575,'10'0'0,"12"1"0,10 1 0,20 0 0,-13 2 0,4-2 0,-23 0 0,-8-1 0,-7-1 0,-4 0 0,8 1 0,1 0 0,1 0 0,-3-1 0,0-1 0,7-1 0,0 0 0,1 0 0,-11 1 0,-3 1 0,-2 0 0,-2 0 0</inkml:trace>
+</inkml:ink>
+</file>
+
+<file path=ppt/ink/ink11.xml><?xml version="1.0" encoding="utf-8"?>
+<inkml:ink xmlns:inkml="http://www.w3.org/2003/InkML">
+  <inkml:definitions>
+    <inkml:context xml:id="ctx0">
+      <inkml:inkSource xml:id="inkSrc0">
+        <inkml:traceFormat>
+          <inkml:channel name="X" type="integer" min="-2.14748E9" max="2.14748E9" units="cm"/>
+          <inkml:channel name="Y" type="integer" min="-2.14748E9" max="2.14748E9" units="cm"/>
+          <inkml:channel name="F" type="integer" max="32767" units="dev"/>
+        </inkml:traceFormat>
+        <inkml:channelProperties>
+          <inkml:channelProperty channel="X" name="resolution" value="1000" units="1/cm"/>
+          <inkml:channelProperty channel="Y" name="resolution" value="1000" units="1/cm"/>
+          <inkml:channelProperty channel="F" name="resolution" value="0" units="1/dev"/>
+        </inkml:channelProperties>
+      </inkml:inkSource>
+      <inkml:timestamp xml:id="ts0" timeString="2026-04-27T07:31:15.777"/>
+    </inkml:context>
+    <inkml:brush xml:id="br0">
+      <inkml:brushProperty name="width" value="0.035" units="cm"/>
+      <inkml:brushProperty name="height" value="0.035" units="cm"/>
+      <inkml:brushProperty name="color" value="#E71224"/>
+    </inkml:brush>
+  </inkml:definitions>
+  <inkml:trace contextRef="#ctx0" brushRef="#br0">0 682 24575,'32'-27'0,"17"-3"0,32-12 0,8-1 0,-44 21 0,1 0 0,3-4 0,1-1 0,-5 3 0,2 0 0,7-2 0,2 1 0,2 2 0,0 2 0,1 3 0,-1 2 0,-3 1 0,0 1 0,0 1 0,-1 0 0,-4 1 0,-2 0 0,32-9 0,0-2 0,-26 4 0,-2 2 0,-8 6 0,-12 4 0,-6 3 0,-15 3 0,-1 0 0,2-1 0,17-3 0,19 1 0,4-6 0,14 1 0,-20-1 0,-13 2 0,-15 4 0,-14 3 0,12-6 0,0 1 0,7-4 0,-11 6 0,-7 2 0,-6 2 0,-1 0 0</inkml:trace>
+</inkml:ink>
+</file>
+
+<file path=ppt/ink/ink12.xml><?xml version="1.0" encoding="utf-8"?>
+<inkml:ink xmlns:inkml="http://www.w3.org/2003/InkML">
+  <inkml:definitions>
+    <inkml:context xml:id="ctx0">
+      <inkml:inkSource xml:id="inkSrc0">
+        <inkml:traceFormat>
+          <inkml:channel name="X" type="integer" min="-2.14748E9" max="2.14748E9" units="cm"/>
+          <inkml:channel name="Y" type="integer" min="-2.14748E9" max="2.14748E9" units="cm"/>
+          <inkml:channel name="F" type="integer" max="32767" units="dev"/>
+        </inkml:traceFormat>
+        <inkml:channelProperties>
+          <inkml:channelProperty channel="X" name="resolution" value="1000" units="1/cm"/>
+          <inkml:channelProperty channel="Y" name="resolution" value="1000" units="1/cm"/>
+          <inkml:channelProperty channel="F" name="resolution" value="0" units="1/dev"/>
+        </inkml:channelProperties>
+      </inkml:inkSource>
+      <inkml:timestamp xml:id="ts0" timeString="2026-04-27T07:31:18.886"/>
+    </inkml:context>
+    <inkml:brush xml:id="br0">
+      <inkml:brushProperty name="width" value="0.035" units="cm"/>
+      <inkml:brushProperty name="height" value="0.035" units="cm"/>
+      <inkml:brushProperty name="color" value="#E71224"/>
+    </inkml:brush>
+  </inkml:definitions>
+  <inkml:trace contextRef="#ctx0" brushRef="#br0">0 1614 8191,'69'-16'0,"-14"5"0,9-1 1071,16-2 0,12-2 0,6 0-1071,-24 2 0,4 0 0,3-1 0,1 0 0,1 0 0,8 0 0,2-1 0,1 0 0,1 0 0,-1-1 0,-2 0 0,0 0 0,0-1 0,-1 1 0,-2 0 0,-7 2 0,-2 0 0,0 0 0,-3 0 0,-1 1 0,7-1 0,-3 0 0,-2 0 0,-2 0 648,13-2 1,-2-1 0,3 0-649,-5 1 0,4 0 0,2-2 0,-1 0 0,0-1 0,0-2 0,1 1 0,4-1-39,-4 4 1,3-1 0,3 0 0,2 0 0,2 0 38,-17 2 0,3 0 0,2-1 0,1 1 0,0-1 0,0 2 0,-3 0 0,8 0 0,-1 1 0,-1 1 0,0-1 0,0 1 0,1 0 0,4-1 0,0 0 0,1-1 0,0 1 0,-2 1 0,-2-1 418,-9 3 0,-1-1 0,-2 1 1,0 0-1,-2 0 0,0 0-418,11-2 0,-3-1 0,0 1 0,-1-1 0,-1 1 0,-5 2 0,-2-1 1,0 1-1,-1 0 1,1-1-1,1-1 0,0-1 0,1 0 0,-3 1 0,-2 1 89,2 0 0,-3 1 0,-1 1 0,-2-1-89,19-3 0,-1 1 0,-2 1 0,-8 2 0,0 2 0,-3 1 0,-4 2 0,-2 1 0,3 1 0,13 1 0,3 0 0,2 0 0,3-2 0,2 0 0,-3 0 0,-7 0 0,-3 0 0,0-2 0,-4-4 0,-1-2 0,-7 0 1463,-5 0 1,-8-1-1464,23-12 2542,-49 16-2542,-26 8 2076,-6 2-2076,-1-1 0,-2 1 0</inkml:trace>
+</inkml:ink>
+</file>
+
+<file path=ppt/ink/ink13.xml><?xml version="1.0" encoding="utf-8"?>
+<inkml:ink xmlns:inkml="http://www.w3.org/2003/InkML">
+  <inkml:definitions>
+    <inkml:context xml:id="ctx0">
+      <inkml:inkSource xml:id="inkSrc0">
+        <inkml:traceFormat>
+          <inkml:channel name="X" type="integer" min="-2.14748E9" max="2.14748E9" units="cm"/>
+          <inkml:channel name="Y" type="integer" min="-2.14748E9" max="2.14748E9" units="cm"/>
+          <inkml:channel name="F" type="integer" max="32767" units="dev"/>
+        </inkml:traceFormat>
+        <inkml:channelProperties>
+          <inkml:channelProperty channel="X" name="resolution" value="1000" units="1/cm"/>
+          <inkml:channelProperty channel="Y" name="resolution" value="1000" units="1/cm"/>
+          <inkml:channelProperty channel="F" name="resolution" value="0" units="1/dev"/>
+        </inkml:channelProperties>
+      </inkml:inkSource>
+      <inkml:timestamp xml:id="ts0" timeString="2026-04-27T07:20:06.779"/>
+    </inkml:context>
+    <inkml:brush xml:id="br0">
+      <inkml:brushProperty name="width" value="0.035" units="cm"/>
+      <inkml:brushProperty name="height" value="0.035" units="cm"/>
+      <inkml:brushProperty name="color" value="#E71224"/>
+    </inkml:brush>
+  </inkml:definitions>
+  <inkml:trace contextRef="#ctx0" brushRef="#br0">5098 3 24575,'-96'-1'0,"35"0"0,-10 1 0,5 0 0,-10 1 0,-4 0 0,0 0-839,-4 1 1,-2-1-1,-1 1 1,0 0 838,-3 1 0,-1 0 0,0 0 0,1 1 0,1 1 0,-1 0 0,3 1 0,6 1 93,4 1 0,5 2 0,0 3-93,-10 5 0,0 5 0,0 3 0,0 7 0,1 5 0,-1 2-268,-1 4 1,0 3-1,-2 4 268,10-2 0,-2 3 0,1 2 0,1 0 0,4 0 0,1 1 0,1 1 0,2-1 0,5-3 0,1-1 0,2 1 0,-1 1 0,-3 5 0,0 2 0,1-1 0,5-3-198,2-1 0,5-1 0,-1 2 198,-7 9 0,0 4 0,2 3 0,2 3 0,1 3 0,2 2-104,1 2 1,1 2 0,-1 5 103,13-20 0,-1 4 0,-1 2 0,2 1 0,0 1-301,2 1 1,0 2-1,1 0 1,1 1 0,1 0 300,0-1 0,0-1 0,2 1 0,1 1 0,1 2 0,0 10 0,2 3 0,1 1 0,2-1 0,1-2 0,4-12 0,1-2 0,2-1 0,0 0 0,2 1 0,1 2 0,1 1 0,1 0 0,1 0 0,0 1 0,0 5 0,0 2 0,0 0 0,1-2 0,1-3 0,0 0 0,1-4 0,1 0 0,0 4 0,1-5 0,0 2 0,1 2 0,-1 0 0,2-2 0,-1 16 0,1-2 0,1 0 0,0-2 4,1-7 0,0-2 0,1 0 0,1 2-4,0 4 0,2 2 0,0-1 0,0-6 57,2 2 0,1-5 0,1-3-57,0-9 0,1-3 0,2 1 0,1 1 0,3 1 0,1-4 0,9 20 0,5-2 0,-1-17 0,4 2 0,4-2 0,4 2 0,4-2 0,1-2 0,-3-9 0,1-2 0,2-1 0,3 1 0,2-2 0,-2-4 828,6 5 0,-1-5-828,-3-7 0,-1-1 1142,3-1 1,-1 1-1143,-3-1 0,1 1 829,7 7 1,3 2-830,3 2 0,2 1 0,6 2 0,3 0 0,-2-5 0,-1-2 248,0-5 1,-4-3-249,-16-12 0,-3-3 0,31 11 0,-37-18 0,1-2 0,-8-2 0,10 4 0,2 1 0,-3 0 0,0 1 0,-10-4 0,13 5 0,-10-8 0,9-1 0,-17-7 0,-8-3 0,-12-3 0,-6-1 0,3-1 0,6-3 0,0 2 0,-2-2 0,-2 5 0,5 8 0,8 5 0,14 8 0,1-3 0,-10-4 0,-10-9 0,-13-4 0,-3-1 0,0-4 0,-1-10 0,-2 4 0,2-4 0,-1 11 0</inkml:trace>
+</inkml:ink>
+</file>
+
+<file path=ppt/ink/ink14.xml><?xml version="1.0" encoding="utf-8"?>
+<inkml:ink xmlns:inkml="http://www.w3.org/2003/InkML">
+  <inkml:definitions>
+    <inkml:context xml:id="ctx0">
+      <inkml:inkSource xml:id="inkSrc0">
+        <inkml:traceFormat>
+          <inkml:channel name="X" type="integer" min="-2.14748E9" max="2.14748E9" units="cm"/>
+          <inkml:channel name="Y" type="integer" min="-2.14748E9" max="2.14748E9" units="cm"/>
+          <inkml:channel name="F" type="integer" max="32767" units="dev"/>
+        </inkml:traceFormat>
+        <inkml:channelProperties>
+          <inkml:channelProperty channel="X" name="resolution" value="1000" units="1/cm"/>
+          <inkml:channelProperty channel="Y" name="resolution" value="1000" units="1/cm"/>
+          <inkml:channelProperty channel="F" name="resolution" value="0" units="1/dev"/>
+        </inkml:channelProperties>
+      </inkml:inkSource>
+      <inkml:timestamp xml:id="ts0" timeString="2026-04-27T07:20:08.845"/>
+    </inkml:context>
+    <inkml:brush xml:id="br0">
+      <inkml:brushProperty name="width" value="0.035" units="cm"/>
+      <inkml:brushProperty name="height" value="0.035" units="cm"/>
+      <inkml:brushProperty name="color" value="#E71224"/>
+    </inkml:brush>
+  </inkml:definitions>
+  <inkml:trace contextRef="#ctx0" brushRef="#br0">422 1 24575,'17'28'0,"5"2"0,16 20 0,-1-7 0,-2-3 0,-13-13 0,-10-10 0,-4-1 0,3 12 0,0 1 0,6 14 0,-3-8 0,3 6 0,2 4 0,-4-6 0,0-3 0,-7-18 0,-4-10 0,-1-3 0,-2-2 0,0 0 0,0-1 0,1 1 0,1 7 0,2 4 0,1 3 0,-1-2 0,-1-7 0,-2-5 0,-1-5 0,-1-1 0,-2 0 0,-5-2 0,-20-6 0,-23-9 0,-15-5 0,-12-6 0,12 5 0,7 3 0,8 7 0,11 7 0,1 3 0,11 4 0,-2 0 0,-5 2 0,-3-1 0,-8 2 0,9 1 0,13 0 0,8 0 0,11-2 0,3 1 0,-1 0 0,-1 2 0,-6 2 0,-1 1 0,2-2 0,0-9-1696,5-10 0,-1 3 0,2 0 0</inkml:trace>
+</inkml:ink>
+</file>
+
+<file path=ppt/ink/ink15.xml><?xml version="1.0" encoding="utf-8"?>
+<inkml:ink xmlns:inkml="http://www.w3.org/2003/InkML">
+  <inkml:definitions>
+    <inkml:context xml:id="ctx0">
+      <inkml:inkSource xml:id="inkSrc0">
+        <inkml:traceFormat>
+          <inkml:channel name="X" type="integer" min="-2.14748E9" max="2.14748E9" units="cm"/>
+          <inkml:channel name="Y" type="integer" min="-2.14748E9" max="2.14748E9" units="cm"/>
+          <inkml:channel name="F" type="integer" max="32767" units="dev"/>
+        </inkml:traceFormat>
+        <inkml:channelProperties>
+          <inkml:channelProperty channel="X" name="resolution" value="1000" units="1/cm"/>
+          <inkml:channelProperty channel="Y" name="resolution" value="1000" units="1/cm"/>
+          <inkml:channelProperty channel="F" name="resolution" value="0" units="1/dev"/>
+        </inkml:channelProperties>
+      </inkml:inkSource>
+      <inkml:timestamp xml:id="ts0" timeString="2026-04-27T07:32:37.655"/>
+    </inkml:context>
+    <inkml:brush xml:id="br0">
+      <inkml:brushProperty name="width" value="0.035" units="cm"/>
+      <inkml:brushProperty name="height" value="0.035" units="cm"/>
+      <inkml:brushProperty name="color" value="#E71224"/>
+    </inkml:brush>
+  </inkml:definitions>
+  <inkml:trace contextRef="#ctx0" brushRef="#br0">0 2709 24575,'6'-20'0,"-1"-4"0,0-19 0,-2-24 0,0 10 0,-2-2 0,1-5 0,-1-34 0,1 20 0,-1-2 0,-1 19 0,1 1 0,0-10 0,2 1 0,-1 17 0,2 1 0,3-12 0,1-3 0,5-3 0,2 0 0,-1 2 0,2 1 0,1-2 0,0 3 0,-2 14 0,-1 4 0,9-21 0,10 1 0,6 10 0,24-13 0,-21 32 0,6-1 0,18-10 0,6 0 0,7 0 0,4 3-271,-15 11 1,3 0 0,1 3 270,2 1 0,2 3 0,-1 1 0,-2 3 0,-1 2 0,2 0 0,13-2 0,2 1 0,-1 0 0,-6 3 0,-1 1 0,1 1 0,6 0 0,0 0 0,2 3 0,1 0 0,2 1 0,-2 3 0,-6 2 0,0 2 0,0 2 0,0 0 0,0 2 0,-1 0 0,-3 2 0,-1 0 0,-2 1 0,-9-1 0,-1 1 0,-4-1 0,13 2 0,-3 0 0,-7-3 0,-5 0 0,9 0 0,0-2 0,-20 3 0,-8 0 811,9 2-811,14 0 0,-10-1 0,6 1 0,12-1 0,4 1 0,13-1 0,-1-1 0,-23 1 0,-6-1 0,22 0 0,-57-5 0,-20 1 0,4-2 0,1 1 0,6-1 0,9-2 0,11-2 0,-3 3 0,4 2 0,-11 3 0,-1 2 0,-10 0 0,-9 1 0,-5-1 0,-3 0 0,2 1 0,0-2 0</inkml:trace>
+</inkml:ink>
+</file>
+
+<file path=ppt/ink/ink16.xml><?xml version="1.0" encoding="utf-8"?>
+<inkml:ink xmlns:inkml="http://www.w3.org/2003/InkML">
+  <inkml:definitions>
+    <inkml:context xml:id="ctx0">
+      <inkml:inkSource xml:id="inkSrc0">
+        <inkml:traceFormat>
+          <inkml:channel name="X" type="integer" min="-2.14748E9" max="2.14748E9" units="cm"/>
+          <inkml:channel name="Y" type="integer" min="-2.14748E9" max="2.14748E9" units="cm"/>
+          <inkml:channel name="F" type="integer" max="32767" units="dev"/>
+        </inkml:traceFormat>
+        <inkml:channelProperties>
+          <inkml:channelProperty channel="X" name="resolution" value="1000" units="1/cm"/>
+          <inkml:channelProperty channel="Y" name="resolution" value="1000" units="1/cm"/>
+          <inkml:channelProperty channel="F" name="resolution" value="0" units="1/dev"/>
+        </inkml:channelProperties>
+      </inkml:inkSource>
+      <inkml:timestamp xml:id="ts0" timeString="2026-04-27T07:32:38.732"/>
+    </inkml:context>
+    <inkml:brush xml:id="br0">
+      <inkml:brushProperty name="width" value="0.035" units="cm"/>
+      <inkml:brushProperty name="height" value="0.035" units="cm"/>
+      <inkml:brushProperty name="color" value="#E71224"/>
+    </inkml:brush>
+  </inkml:definitions>
+  <inkml:trace contextRef="#ctx0" brushRef="#br0">697 72 24575,'-15'-2'0,"-15"0"0,-28-3 0,-30-6 0,36 4 0,0 0 0,-38-7 0,16 2 0,34 7 0,17 3 0,7 0 0,7 2 0,-6 0 0,-14 0 0,-7 0 0,3-1 0,10 0 0,13 1 0,8 0 0,1 0 0,0 0 0</inkml:trace>
+</inkml:ink>
+</file>
+
+<file path=ppt/ink/ink17.xml><?xml version="1.0" encoding="utf-8"?>
+<inkml:ink xmlns:inkml="http://www.w3.org/2003/InkML">
+  <inkml:definitions>
+    <inkml:context xml:id="ctx0">
+      <inkml:inkSource xml:id="inkSrc0">
+        <inkml:traceFormat>
+          <inkml:channel name="X" type="integer" min="-2.14748E9" max="2.14748E9" units="cm"/>
+          <inkml:channel name="Y" type="integer" min="-2.14748E9" max="2.14748E9" units="cm"/>
+          <inkml:channel name="F" type="integer" max="32767" units="dev"/>
+        </inkml:traceFormat>
+        <inkml:channelProperties>
+          <inkml:channelProperty channel="X" name="resolution" value="1000" units="1/cm"/>
+          <inkml:channelProperty channel="Y" name="resolution" value="1000" units="1/cm"/>
+          <inkml:channelProperty channel="F" name="resolution" value="0" units="1/dev"/>
+        </inkml:channelProperties>
+      </inkml:inkSource>
+      <inkml:timestamp xml:id="ts0" timeString="2026-04-27T07:32:40.065"/>
+    </inkml:context>
+    <inkml:brush xml:id="br0">
+      <inkml:brushProperty name="width" value="0.035" units="cm"/>
+      <inkml:brushProperty name="height" value="0.035" units="cm"/>
+      <inkml:brushProperty name="color" value="#E71224"/>
+    </inkml:brush>
+  </inkml:definitions>
+  <inkml:trace contextRef="#ctx0" brushRef="#br0">479 0 24575,'-40'15'0,"-3"0"0,-15 6 0,9-4 0,13-4 0,10-3 0,8-3 0,0 1 0,-11 7 0,0 2 0,-4 5 0,6-1 0,8-4 0,8-7 0,6-5 0,3-3 0,0-2 0,-8 5-1696,2-1 0,-3 3 0,6-4 0</inkml:trace>
+</inkml:ink>
+</file>
+
+<file path=ppt/ink/ink2.xml><?xml version="1.0" encoding="utf-8"?>
+<inkml:ink xmlns:inkml="http://www.w3.org/2003/InkML">
+  <inkml:definitions>
+    <inkml:context xml:id="ctx0">
+      <inkml:inkSource xml:id="inkSrc0">
+        <inkml:traceFormat>
+          <inkml:channel name="X" type="integer" min="-2.14748E9" max="2.14748E9" units="cm"/>
+          <inkml:channel name="Y" type="integer" min="-2.14748E9" max="2.14748E9" units="cm"/>
+          <inkml:channel name="F" type="integer" max="32767" units="dev"/>
+        </inkml:traceFormat>
+        <inkml:channelProperties>
+          <inkml:channelProperty channel="X" name="resolution" value="1000" units="1/cm"/>
+          <inkml:channelProperty channel="Y" name="resolution" value="1000" units="1/cm"/>
+          <inkml:channelProperty channel="F" name="resolution" value="0" units="1/dev"/>
+        </inkml:channelProperties>
+      </inkml:inkSource>
+      <inkml:timestamp xml:id="ts0" timeString="2026-04-27T07:19:59.529"/>
+    </inkml:context>
+    <inkml:brush xml:id="br0">
+      <inkml:brushProperty name="width" value="0.035" units="cm"/>
+      <inkml:brushProperty name="height" value="0.035" units="cm"/>
+      <inkml:brushProperty name="color" value="#E71224"/>
+    </inkml:brush>
+  </inkml:definitions>
+  <inkml:trace contextRef="#ctx0" brushRef="#br0">21330 315 24575,'-70'-9'0,"-18"2"0,2 1 0,-11-1 0,15 3 0,-6 1 0,-1-1-999,-2 0 0,-2-1 1,-3 1 998,8 0 0,-4 1 0,1-1 0,4 1 0,-5 1 0,4-1 0,1 1 17,-1 1 1,0 0-1,1 0-17,8 3 0,1 0 0,2 0 0,6 1 0,1 1 0,-3-1 0,-13 1 0,-5 0 0,-2 1-261,13-1 0,-3 0 0,0 0 1,-1-1 260,-1 0 0,1 1 0,-3-2 0,-5 0-513,10-2 1,-5 0 0,-2-1 0,-3 0 0,1 0-1,1 0 513,2 0 0,-1-1 0,1 1 0,0-1 0,-1 0 0,1-1 0,-1 1 0,-1-2 0,1 1 0,0 0 0,-1-1 0,0 2-144,-1-1 0,-2 1 1,-1 0-1,2 1 1,2-1-1,4 1 144,-16 1 0,4 0 0,2 0 0,0 0-175,-2 1 0,0-1 1,1 1-1,2-1 175,5 1 0,1 1 0,2-1 0,2-1 0,-15 1 0,3-1 0,-5-1 0,8 1 0,-6-1 0,0 1 0,0-1 0,6 1 0,0-1 0,-1 1 0,0 0 0,15-1 0,0 1 0,-2-1 0,1 1 0,-1-1-43,-4 1 0,-1 0 0,0 0 0,1 0 0,2 0 43,-10 0 0,3-1 0,0 1 0,0 0 0,-3-1 0,0 0 0,-1 0 0,0 0 0,-5 0 0,-1 0 0,1-1 0,2 0 0,10 1 0,2-1 0,0-1 0,-3 1 0,8 0 0,-2 0 0,-1-1 0,-1 1 0,2 0 0,0-1 0,1 1 0,-1-1 0,2 1 0,0 0 0,-15-2 0,2 1 0,0 0 0,-2 0 0,11 1 0,-3 0 0,1 1 0,-1 0 0,3-1 0,-12 0 0,2-1 0,1 0 0,-1 1 0,-1 1 0,1 1 0,-1 0 0,-2-1 0,13-1 0,-3 0 0,1-1 0,0 1 0,4-1 0,-5 2 0,3-1 0,1 1 0,-4-1 0,8 0 0,-2 0 0,-2 0 0,2 0 0,3 0 444,-5 0 0,2 0 0,3 0 0,-1 0-444,3 0 0,0 0 0,1 0 0,0 0 0,0-1 0,-1 1 0,1-1 0,1 0 0,-20 0 0,1-1 0,0 0 0,1 0 0,0 0 0,2 0 534,5 0 1,1 0-1,1 1-534,8-1 0,0 0 0,2 0 0,-26 0 0,-1-1 0,26 2 0,-1 0 0,0 0 0,3 0 0,0 0 0,0 0 0,3 1 0,1 0 0,0-1 745,-31-1 0,3 0-745,16 2 0,3 0 1038,6 0 0,1-1-1038,-9 1 0,1 0 617,15 1 0,0 0-617,-10 0 0,1 0 329,9 0 0,2 0-329,7 0 0,1 0 0,-6 0 0,1 0 0,3 0 0,2-1 0,-45 1 0,43 0 0,0-1 0,-39 2 0,42 0 0,-2 1 0,-3-1 0,1 1 0,5-1 0,1 1 0,-7-1 0,0 1 0,2-2 0,2 0 0,2 1 0,1 0 0,-5-1 0,2 0 0,-35 1 0,-4 0 0,7 0 0,20 0 0,3 0 0,5 0 0,2 0 0,-16 0 0,10 0 0,-3 0 0,-11 0 0,-11 0 0,35 0 0,-3 0 0,-9 1 0,0-1 0,9 1 0,0 0 0,-6 0 0,0 2 0,9 0 0,1 0 0,-47 5 0,44-1 0,0 0 0,-41 8 0,45-7 0,-1-1 0,-48 7 0,23-5 0,-3 0 0,6 0 0,7 1 0,-14 7 0,9 7 0,7 9 0,-8 21 0,14 9 0,25-20 0,1 2 0,2 1 0,2 0 0,3 0 0,2-1 0,-15 35 0,11-4 0,11-7 0,3 20 0,8-6 0,0 11 0,5 1 0,5-7 0,6 6 0,9-14 0,7-4 0,13 4 0,7-4 0,-18-34 0,4 0 0,11 4 0,4 0 0,4-1 0,4-1 0,15 7 0,3-1 0,1-2 0,0-3 0,-9-3 0,1-1 0,12 6 0,3-2 0,0-3 0,3-2 0,-25-13 0,1-1 0,3-1-207,15 2 0,4-2 0,-2-3 207,-14-6 0,-2-3 0,1-1 0,5 1 0,2-2 0,-3-1 0,22 0 0,-4-4 0,-6-1 0,-1-2 0,11 0 0,3-1-269,-28 0 1,1-2 0,2 2 268,10 0 0,2 0 0,5 1-430,-5-1 0,5 1 0,1-1 0,-2 1 430,-6 0 0,-1 0 0,0 0 0,2 0 0,8 0 0,2 0 0,-1-1 0,-3 0-127,14 1 1,-4 0 0,-1-1 126,-10-1 0,-2 0 0,3 0 0,-13-1 0,2-1 0,1 0 0,3-1-506,11-1 0,4-2 0,1 0 0,0 0 506,-18 1 0,-1 0 0,1 0 0,2 1 0,3-1-296,4 0 0,4 1 0,3-1 0,0 1 0,-2 0 1,-4 0 295,0 0 0,-4 1 0,-1-1 0,0 2 0,2-1 0,8 1 0,2 1 0,0 1 0,-1-1 0,-1 0-61,-7 0 1,-1 0 0,-1 0 0,-1 0-1,-2 0 61,10 0 0,-3 0 0,0 0 0,4 0 0,-8 0 0,2-1 0,1 1 0,1 0 0,-2-1 0,-3 1 0,-2-1 0,1 1 0,-1 0 0,0 0 0,18 0 0,-1 0 0,0 1 0,1-1 0,-18 1 0,2 0 0,-1 0 0,-3 0 0,-3 0 31,23 1 1,-5-1 0,-1 1-32,-1-1 0,0 0 0,-3-1 0,-9-1 0,-2-1 0,1-1 0,-2 0 0,0-2 0,3 0 0,15 0 0,3-2 0,0 1 0,-1 0 0,0-1 0,-1 1 0,-11 1 0,-1-1 0,3 1 148,-9 0 1,4 1 0,0-1 0,-2 1-149,15-3 0,-3 1 0,3 0 0,-13 0 0,2-1 0,2 1 0,0-2 0,8 0 0,2-1 0,0 0 0,-4 0 0,-12 0 0,-2 1 0,-1-1 0,3 1 0,9-1 0,2 0 0,1 0 0,-1 1 0,-5 1 0,0-1 0,-1 1 0,-2 1 0,-7 2 0,-1 0 0,-2 0 0,2 0 0,4 1 0,0 0 0,0 0 0,-2 0 612,13-1 0,-2 1 0,-2-1-612,-6 1 0,-3-1 0,3 0 0,12 1 0,1 0 0,-2-1 0,-15 2 0,-2 0 0,1 0 0,9 0 0,2-1 0,-2-1 0,-1 0 0,0-2 0,-2-1 0,-9 1 0,0 0 0,0-1 0,5 0 0,1-2 0,-1 2 0,-6 2 0,-1 0 0,-1 1 857,26-1 0,0 0-857,-27 2 0,2 1 0,-2-1 0,22 0 0,0 0 0,-23 0 0,1 1 0,1 0 0,1 0 0,0 1 0,0 0 0,-1-1 0,1 1 0,1-1 0,3-1 0,0 1 0,0 0 0,0-1 0,0 1 0,-2-1 0,-4 0 0,0-1 0,0 0 0,4 1 0,1 0 0,-1 0 0,-5-2 0,-1-1 0,-2 0 0,20-1 0,0-1 398,9-5 1,-3-3-399,-23 3 0,-3-1 766,4-3 0,-1-3-766,-3-2 0,-4-1 810,29-20-810,-43 17 0,-2-2 247,27-21-247,-9 0 0,16-7 0,1 8 0,-33 25 0,1 1 0,43-13 0,-14 12 0,-5-1 0,3-3 0,4-7 0,-24 9 0,1-3 0,-7 4 0,-1-1 0,1-3 0,-3-1 0,31-27 0,-30 13 0,-3-3 0,-13 6 0,-11 7 0,0-8 0,-7 3 0,1 0 0,3-2 0,4-1 0,-3 3 0,0-4 0,-9 11 0,-5-2 0,-1 3 0,-2 3 0,-2-5 0,-7 1 0,-37-22 0,-13 8 0,-12-2 0,-6-1 0,-1 1 0,-1 2 0,5 5 0,22 13 0,10 6 0,20 10 0,19 10 0,2 1 0</inkml:trace>
+</inkml:ink>
+</file>
+
+<file path=ppt/ink/ink3.xml><?xml version="1.0" encoding="utf-8"?>
+<inkml:ink xmlns:inkml="http://www.w3.org/2003/InkML">
+  <inkml:definitions>
+    <inkml:context xml:id="ctx0">
+      <inkml:inkSource xml:id="inkSrc0">
+        <inkml:traceFormat>
+          <inkml:channel name="X" type="integer" min="-2.14748E9" max="2.14748E9" units="cm"/>
+          <inkml:channel name="Y" type="integer" min="-2.14748E9" max="2.14748E9" units="cm"/>
+          <inkml:channel name="F" type="integer" max="32767" units="dev"/>
+        </inkml:traceFormat>
+        <inkml:channelProperties>
+          <inkml:channelProperty channel="X" name="resolution" value="1000" units="1/cm"/>
+          <inkml:channelProperty channel="Y" name="resolution" value="1000" units="1/cm"/>
+          <inkml:channelProperty channel="F" name="resolution" value="0" units="1/dev"/>
+        </inkml:channelProperties>
+      </inkml:inkSource>
+      <inkml:timestamp xml:id="ts0" timeString="2026-04-27T07:20:13.545"/>
+    </inkml:context>
+    <inkml:brush xml:id="br0">
+      <inkml:brushProperty name="width" value="0.035" units="cm"/>
+      <inkml:brushProperty name="height" value="0.035" units="cm"/>
+      <inkml:brushProperty name="color" value="#E71224"/>
+    </inkml:brush>
+  </inkml:definitions>
+  <inkml:trace contextRef="#ctx0" brushRef="#br0">3226 1 24575,'15'6'0,"21"26"0,11 20 0,-11-7 0,-1 6 0,-5 3 0,-2 3 0,3 10 0,-3 3 0,-2 12 0,-3 3 0,-2-1 0,-2 1 0,-3-2 0,-3 0 0,-3 8 0,-4-2 0,-3-11 0,-3 2 0,-1-14 0,-3 4 0,0 0 0,-3-1 0,-1-1 0,-1 1 0,-1-1 0,0-1 0,-2 0 0,-8 31 0,-3-2 0,0-10 0,-2-3 0,0-4 0,-5 0 0,2-19 0,-3 1 0,0-2 0,-7 10 0,0-3 0,-9 9 0,0-3 0,11-18 0,2-4 0,-19 29 0,20-37 0,-1-3 0,-20 15 0,-10 5 0,-12 1 0,-3-6 0,31-23 0,-2-2 0,-4 1 0,1-2 0,4-4 0,0 0 0,-1 0 0,1-1 0,-38 8 0,-7-5 0,27-17 0,-6-4 0,-13 1 0,-4-3-361,16-2 1,-3-1-1,-3 0 361,-13-1 0,-3-1 0,1 0 0,11 1 0,1 0 0,0-1 0,-6 1 0,-1-1 0,7 1 0,-4 1 0,9-1 0,16 1 0,5 0 0,-17 2 0,34-1 0,-3 1 0,10 0 1082,9 0-1082,-12 0 0,-2 0 0,0 1 0,-3 0 0,23-2 0,6 0 0,10-1 0,-13 4 0,4 0 0,-10 2 0,4-2 0,7-2 0,2 0 0,5-2 0,1 0 0,-3-5 0,-1-2 0,2 1 0,1 0 0</inkml:trace>
+</inkml:ink>
+</file>
+
+<file path=ppt/ink/ink4.xml><?xml version="1.0" encoding="utf-8"?>
+<inkml:ink xmlns:inkml="http://www.w3.org/2003/InkML">
+  <inkml:definitions>
+    <inkml:context xml:id="ctx0">
+      <inkml:inkSource xml:id="inkSrc0">
+        <inkml:traceFormat>
+          <inkml:channel name="X" type="integer" min="-2.14748E9" max="2.14748E9" units="cm"/>
+          <inkml:channel name="Y" type="integer" min="-2.14748E9" max="2.14748E9" units="cm"/>
+          <inkml:channel name="F" type="integer" max="32767" units="dev"/>
+        </inkml:traceFormat>
+        <inkml:channelProperties>
+          <inkml:channelProperty channel="X" name="resolution" value="1000" units="1/cm"/>
+          <inkml:channelProperty channel="Y" name="resolution" value="1000" units="1/cm"/>
+          <inkml:channelProperty channel="F" name="resolution" value="0" units="1/dev"/>
+        </inkml:channelProperties>
+      </inkml:inkSource>
+      <inkml:timestamp xml:id="ts0" timeString="2026-04-27T07:20:16.080"/>
+    </inkml:context>
+    <inkml:brush xml:id="br0">
+      <inkml:brushProperty name="width" value="0.035" units="cm"/>
+      <inkml:brushProperty name="height" value="0.035" units="cm"/>
+      <inkml:brushProperty name="color" value="#E71224"/>
+    </inkml:brush>
+  </inkml:definitions>
+  <inkml:trace contextRef="#ctx0" brushRef="#br0">729 0 24575,'-25'6'0,"-29"7"0,-10 3 0,-11 6 0,16 0 0,11-2 0,5-1 0,6-2 0,7-4 0,-1 0 0,0-1 0,0-2 0,-12 3 0,4-3 0,-7 1 0,13-3 0,14-3 0,10-2 0,5 1 0,1 0 0,-1 0 0,3-1 0,6 3 0,10 7 0,15 7 0,18 9 0,4-2 0,9-1 0,-6-6 0,4-4 0,0-3 0,-8-5 0,1 0 0,-8 0 0,-7-1 0,2 0 0,-7-1 0,-9-2 0,1 4 0,-14-4 0,8 6 0,-12-6 0,5 3 0,-13-8 0,1 0 0</inkml:trace>
+</inkml:ink>
+</file>
+
+<file path=ppt/ink/ink5.xml><?xml version="1.0" encoding="utf-8"?>
+<inkml:ink xmlns:inkml="http://www.w3.org/2003/InkML">
+  <inkml:definitions>
+    <inkml:context xml:id="ctx0">
+      <inkml:inkSource xml:id="inkSrc0">
+        <inkml:traceFormat>
+          <inkml:channel name="X" type="integer" min="-2.14748E9" max="2.14748E9" units="cm"/>
+          <inkml:channel name="Y" type="integer" min="-2.14748E9" max="2.14748E9" units="cm"/>
+          <inkml:channel name="F" type="integer" max="32767" units="dev"/>
+        </inkml:traceFormat>
+        <inkml:channelProperties>
+          <inkml:channelProperty channel="X" name="resolution" value="1000" units="1/cm"/>
+          <inkml:channelProperty channel="Y" name="resolution" value="1000" units="1/cm"/>
+          <inkml:channelProperty channel="F" name="resolution" value="0" units="1/dev"/>
+        </inkml:channelProperties>
+      </inkml:inkSource>
+      <inkml:timestamp xml:id="ts0" timeString="2026-04-27T07:20:32.178"/>
+    </inkml:context>
+    <inkml:brush xml:id="br0">
+      <inkml:brushProperty name="width" value="0.035" units="cm"/>
+      <inkml:brushProperty name="height" value="0.035" units="cm"/>
+      <inkml:brushProperty name="color" value="#E71224"/>
+    </inkml:brush>
+  </inkml:definitions>
+  <inkml:trace contextRef="#ctx0" brushRef="#br0">7358 400 24575,'-82'-20'0,"20"6"0,-6-2 0,-19-4 0,-8-1-456,17 3 0,-4 0 1,3 0 455,9 3 0,2 0 0,0 1 0,-31-6 0,3 2 222,13 4 1,3 3-223,11 3 0,-2 1 0,-17 0 0,-3 2 0,-7 0 0,-2 1-136,31 1 1,0 1-1,-3-1 136,-7 0 0,-3 0 0,3 0 0,7 0 0,1 1 0,-1-1 0,-3 0 0,-1 0 0,-1-1 0,-8 0 0,-1 1 0,2-1 0,10 2 0,2-1 0,-4 0 0,-16 0 0,-5-1 0,3 1 0,8-1 0,1 1 0,2 0 0,3 1 0,2 0 0,-3-1 0,-7 0 0,-3 0 0,4 0 0,12-1 0,3 1 0,-1 1 0,-1-1 0,0 1 0,0 0 0,0 0 0,0 0 0,4 1 0,-10 1 0,1 0 0,-8 0 0,1 1 336,11-1 1,2 1-337,5 1 0,0 0 0,-6 2 0,0 1 0,-1 0 0,0 0 328,3 3 0,-2-1-328,-10 1 0,0 0 0,16 0 0,1 0 0,-1 1 0,0 1 0,-1 1 0,2 1 0,8-1 0,0 2 0,-7 2 0,1 2 0,5 1 0,4 0 0,-28 16 0,-1 14 0,30 0 0,-8 17 0,31-25 0,1 3 0,2-2 0,1 1 0,-3 6 0,2 0 0,5-2 0,2-1 0,-10 38 0,12 11 0,13-10 0,10-4 0,4-7 0,7-20 0,7 6 0,8 0 0,21 14 0,-7-22 0,5 2 0,15 11 0,3 1 0,-3-4 0,3 0 0,-11-10 0,3 1 0,-4-5 0,-3-3 0,-1-3 0,15 9 0,1-5 0,-11-15 0,0-6 0,2-6 0,1-3 0,8-3 0,1-3 0,-3-5 0,-2-3 0,-8-1 0,-1-1 0,5 0 0,0 0 0,-7-1 0,1 1 0,12 1 0,6 1 0,21 2 0,4 2 0,0 0 0,3 0-148,-24-2 1,2 1 0,-2-1 147,-5-1 0,-2-1 0,-2 0 0,17-1 0,-3-3 0,1-2 0,-2-2 0,-13 1 0,-2-1 0,-1-1 0,0 0 0,-3 3 0,-1 0 0,41-1 221,-48 5 0,0 0-221,7 1 0,0-1 0,-2 1 0,2 0 0,14 0 0,4 0 0,-3 0 0,1 0 0,2 0 0,3 1 0,-10 0 0,3 1 0,-1 0 0,26 0 0,0 1 0,-25 0 0,2 0 0,-2 0 0,24-1 0,-4-1 0,-17-1 0,-4-1 0,-2-4 0,0-1 0,-2-1 0,-1-2 0,-6 1 0,1-1 0,11-4 0,-1-1 0,-10 5 0,0 0 0,6-3 0,2 0 0,0 3 0,0 1 0,-2 0 0,1 2 0,9-1 0,0 1 0,-2 1 0,-3 0 0,-8 0 0,-3 0 0,1 0 0,-3-1 0,16-8 0,-7-2 0,-13-7 0,-3-5 0,10-12 0,3-4 0,-8 0 0,-4-4 0,-12 6 0,-10 6 0,-5-3 0,-12 10 0,0-13 0,-1-7 0,2-4 0,3-11 0,-1 5 0,-3 8 0,-7 6 0,-3 16 0,-2-2 0,-2 1 0,1-2 0,0-9 0,1-1 0,0 6 0,-1-1 0,0 11 0,0-3 0,-1 0 0,-1-1 0,-1-3 0,-2-4 0,-1 3 0,1 3 0,0 10 0,2 5 0,0-1 0,1 2 0,-1 0 0,1 7 0,0 2 0,-3-3 0,1 2 0,-3-6 0,-6-1 0,-16-9 0,-15-4 0,5 5 0,9 9 0,20 10 0</inkml:trace>
+</inkml:ink>
+</file>
+
+<file path=ppt/ink/ink6.xml><?xml version="1.0" encoding="utf-8"?>
+<inkml:ink xmlns:inkml="http://www.w3.org/2003/InkML">
+  <inkml:definitions>
+    <inkml:context xml:id="ctx0">
+      <inkml:inkSource xml:id="inkSrc0">
+        <inkml:traceFormat>
+          <inkml:channel name="X" type="integer" min="-2.14748E9" max="2.14748E9" units="cm"/>
+          <inkml:channel name="Y" type="integer" min="-2.14748E9" max="2.14748E9" units="cm"/>
+          <inkml:channel name="F" type="integer" max="32767" units="dev"/>
+        </inkml:traceFormat>
+        <inkml:channelProperties>
+          <inkml:channelProperty channel="X" name="resolution" value="1000" units="1/cm"/>
+          <inkml:channelProperty channel="Y" name="resolution" value="1000" units="1/cm"/>
+          <inkml:channelProperty channel="F" name="resolution" value="0" units="1/dev"/>
+        </inkml:channelProperties>
+      </inkml:inkSource>
+      <inkml:timestamp xml:id="ts0" timeString="2026-04-27T07:20:35.470"/>
+    </inkml:context>
+    <inkml:brush xml:id="br0">
+      <inkml:brushProperty name="width" value="0.035" units="cm"/>
+      <inkml:brushProperty name="height" value="0.035" units="cm"/>
+      <inkml:brushProperty name="color" value="#E71224"/>
+    </inkml:brush>
+  </inkml:definitions>
+  <inkml:trace contextRef="#ctx0" brushRef="#br0">0 2653 24575,'14'-6'0,"23"-13"0,29-12 0,-8 4 0,5-1 0,1-1 0,2-1 0,9-3 0,0-2 0,-6 3 0,-2-1 0,-12 6 0,-1 0 0,3-4 0,-2 0 0,-3 0 0,-1-1 0,-3-2 0,0 0 0,7-4 0,-3 0 0,27-21 0,1 4 0,-8 4 0,-6 4 0,4-4 0,1 1 0,-6 2 0,9-8 0,-10 2 0,4-2 0,5-6 0,0 6 0,-31 25 0,0-1 0,1 0 0,0 1 0,34-26 0,-38 26 0,-1-2 0,29-29 0,-11 2 0,6-10 0,-17 18 0,8-9 0,-8 10 0,1-4 0,0 0 0,0 1 0,-9 12 0,9-12 0,-9 11 0,9-13 0,3-2 0,-3 4 0,5 0 0,1 7 0,-9 11 0,-3 2 0,-18 16 0,-6 3 0,-7 8 0,-4 3 0,1 0 0,0 0 0,1 0 0,1 0 0,-2 1 0,-1-1 0,4-2 0,4-3 0,1-1 0,-1 1 0,-7 5 0,-2 1 0,-2 0 0,2-1 0,1-3 0,0 1 0,-2 3 0,-1 1 0,0 1 0,0 0 0,-2 0 0,1 0 0</inkml:trace>
+</inkml:ink>
+</file>
+
+<file path=ppt/ink/ink7.xml><?xml version="1.0" encoding="utf-8"?>
+<inkml:ink xmlns:inkml="http://www.w3.org/2003/InkML">
+  <inkml:definitions>
+    <inkml:context xml:id="ctx0">
+      <inkml:inkSource xml:id="inkSrc0">
+        <inkml:traceFormat>
+          <inkml:channel name="X" type="integer" min="-2.14748E9" max="2.14748E9" units="cm"/>
+          <inkml:channel name="Y" type="integer" min="-2.14748E9" max="2.14748E9" units="cm"/>
+          <inkml:channel name="F" type="integer" max="32767" units="dev"/>
+        </inkml:traceFormat>
+        <inkml:channelProperties>
+          <inkml:channelProperty channel="X" name="resolution" value="1000" units="1/cm"/>
+          <inkml:channelProperty channel="Y" name="resolution" value="1000" units="1/cm"/>
+          <inkml:channelProperty channel="F" name="resolution" value="0" units="1/dev"/>
+        </inkml:channelProperties>
+      </inkml:inkSource>
+      <inkml:timestamp xml:id="ts0" timeString="2026-04-27T07:20:36.910"/>
+    </inkml:context>
+    <inkml:brush xml:id="br0">
+      <inkml:brushProperty name="width" value="0.035" units="cm"/>
+      <inkml:brushProperty name="height" value="0.035" units="cm"/>
+      <inkml:brushProperty name="color" value="#E71224"/>
+    </inkml:brush>
+  </inkml:definitions>
+  <inkml:trace contextRef="#ctx0" brushRef="#br0">1 0 24575,'35'2'0,"10"2"0,25-3 0,20 2 0,3-3 0,-41 0 0,0 0 0,47 0 0,-13 0 0,-9 0 0,-22-1 0,-10 1 0,-10-1 0,-6 0 0,4 0 0,-8 0 0,-6 0 0,-9 1 0,-10 0 0,0 1 0,0 1 0,0-2 0,1 2 0</inkml:trace>
+</inkml:ink>
+</file>
+
+<file path=ppt/ink/ink8.xml><?xml version="1.0" encoding="utf-8"?>
+<inkml:ink xmlns:inkml="http://www.w3.org/2003/InkML">
+  <inkml:definitions>
+    <inkml:context xml:id="ctx0">
+      <inkml:inkSource xml:id="inkSrc0">
+        <inkml:traceFormat>
+          <inkml:channel name="X" type="integer" min="-2.14748E9" max="2.14748E9" units="cm"/>
+          <inkml:channel name="Y" type="integer" min="-2.14748E9" max="2.14748E9" units="cm"/>
+          <inkml:channel name="F" type="integer" max="32767" units="dev"/>
+        </inkml:traceFormat>
+        <inkml:channelProperties>
+          <inkml:channelProperty channel="X" name="resolution" value="1000" units="1/cm"/>
+          <inkml:channelProperty channel="Y" name="resolution" value="1000" units="1/cm"/>
+          <inkml:channelProperty channel="F" name="resolution" value="0" units="1/dev"/>
+        </inkml:channelProperties>
+      </inkml:inkSource>
+      <inkml:timestamp xml:id="ts0" timeString="2026-04-27T07:20:38.778"/>
+    </inkml:context>
+    <inkml:brush xml:id="br0">
+      <inkml:brushProperty name="width" value="0.035" units="cm"/>
+      <inkml:brushProperty name="height" value="0.035" units="cm"/>
+      <inkml:brushProperty name="color" value="#E71224"/>
+    </inkml:brush>
+  </inkml:definitions>
+  <inkml:trace contextRef="#ctx0" brushRef="#br0">1 77 24575,'10'0'0,"-4"-1"0,6-1 0,8-4 0,20-2 0,22-2 0,25 2 0,8 1 0,-44 4 0,-1 0 0,37-2 0,-27 1 0,-2 0 0,-24 3 0,18-2 0,-3 2 0,23 0 0,17-1 0,7 0 0,-44 0 0,0 1 0,35 0 0,-25 0 0,-17 1 0,-31 1 0,5-1 0,3 0 0,0 0 0,-2 0 0,-15 0 0,-7 0 0,-2 0 0,-20 0 0,1 0 0,-3 0 0,12 0 0</inkml:trace>
+</inkml:ink>
+</file>
+
+<file path=ppt/ink/ink9.xml><?xml version="1.0" encoding="utf-8"?>
+<inkml:ink xmlns:inkml="http://www.w3.org/2003/InkML">
+  <inkml:definitions>
+    <inkml:context xml:id="ctx0">
+      <inkml:inkSource xml:id="inkSrc0">
+        <inkml:traceFormat>
+          <inkml:channel name="X" type="integer" min="-2.14748E9" max="2.14748E9" units="cm"/>
+          <inkml:channel name="Y" type="integer" min="-2.14748E9" max="2.14748E9" units="cm"/>
+          <inkml:channel name="F" type="integer" max="32767" units="dev"/>
+        </inkml:traceFormat>
+        <inkml:channelProperties>
+          <inkml:channelProperty channel="X" name="resolution" value="1000" units="1/cm"/>
+          <inkml:channelProperty channel="Y" name="resolution" value="1000" units="1/cm"/>
+          <inkml:channelProperty channel="F" name="resolution" value="0" units="1/dev"/>
+        </inkml:channelProperties>
+      </inkml:inkSource>
+      <inkml:timestamp xml:id="ts0" timeString="2026-04-27T07:20:41.111"/>
+    </inkml:context>
+    <inkml:brush xml:id="br0">
+      <inkml:brushProperty name="width" value="0.035" units="cm"/>
+      <inkml:brushProperty name="height" value="0.035" units="cm"/>
+      <inkml:brushProperty name="color" value="#E71224"/>
+    </inkml:brush>
+  </inkml:definitions>
+  <inkml:trace contextRef="#ctx0" brushRef="#br0">1 0 24575,'22'6'0,"7"-1"0,3 3 0,1-1 0,-11-3 0,3 1 0,-2 1 0,12 0 0,-5-2 0,-9-1 0,-12-2 0,-7-1 0,-2 1 0,1 0 0,-1 3 0,-1 1 0,-3 8 0,-2 7 0,-3 9 0,-1 7 0,2-2 0,-1 1 0,4-10 0,0-3 0,4-4 0,-2-1 0,2 0 0,0-4 0,1-4 0,0-3 0,0-2 0,0 2 0,0 4 0,-1 0 0,0-3 0,1-1 0,0-6 0,-1 0 0,3-2 0,-2 1 0,3-1 0</inkml:trace>
+</inkml:ink>
 </file>
 
 <file path=ppt/slideLayouts/slideLayout1.xml><?xml version="1.0" encoding="utf-8"?>
@@ -3386,10 +3865,1410 @@
           </a:p>
         </p:txBody>
       </p:sp>
+      <mc:AlternateContent xmlns:mc="http://schemas.openxmlformats.org/markup-compatibility/2006">
+        <mc:Choice xmlns:p14="http://schemas.microsoft.com/office/powerpoint/2010/main" Requires="p14">
+          <p:contentPart p14:bwMode="auto" r:id="rId3">
+            <p14:nvContentPartPr>
+              <p14:cNvPr id="6" name="Freihand 5">
+                <a:extLst>
+                  <a:ext uri="{FF2B5EF4-FFF2-40B4-BE49-F238E27FC236}">
+                    <a16:creationId xmlns:a16="http://schemas.microsoft.com/office/drawing/2014/main" id="{4F632C6F-17BD-4A95-BE1A-E514767B3A32}"/>
+                  </a:ext>
+                </a:extLst>
+              </p14:cNvPr>
+              <p14:cNvContentPartPr/>
+              <p14:nvPr/>
+            </p14:nvContentPartPr>
+            <p14:xfrm>
+              <a:off x="3228000" y="691851"/>
+              <a:ext cx="1259280" cy="463680"/>
+            </p14:xfrm>
+          </p:contentPart>
+        </mc:Choice>
+        <mc:Fallback>
+          <p:pic>
+            <p:nvPicPr>
+              <p:cNvPr id="6" name="Freihand 5">
+                <a:extLst>
+                  <a:ext uri="{FF2B5EF4-FFF2-40B4-BE49-F238E27FC236}">
+                    <a16:creationId xmlns:a16="http://schemas.microsoft.com/office/drawing/2014/main" id="{4F632C6F-17BD-4A95-BE1A-E514767B3A32}"/>
+                  </a:ext>
+                </a:extLst>
+              </p:cNvPr>
+              <p:cNvPicPr/>
+              <p:nvPr/>
+            </p:nvPicPr>
+            <p:blipFill>
+              <a:blip r:embed="rId4"/>
+              <a:stretch>
+                <a:fillRect/>
+              </a:stretch>
+            </p:blipFill>
+            <p:spPr>
+              <a:xfrm>
+                <a:off x="3221880" y="685731"/>
+                <a:ext cx="1271520" cy="475920"/>
+              </a:xfrm>
+              <a:prstGeom prst="rect">
+                <a:avLst/>
+              </a:prstGeom>
+            </p:spPr>
+          </p:pic>
+        </mc:Fallback>
+      </mc:AlternateContent>
+      <mc:AlternateContent xmlns:mc="http://schemas.openxmlformats.org/markup-compatibility/2006">
+        <mc:Choice xmlns:p14="http://schemas.microsoft.com/office/powerpoint/2010/main" Requires="p14">
+          <p:contentPart p14:bwMode="auto" r:id="rId5">
+            <p14:nvContentPartPr>
+              <p14:cNvPr id="7" name="Freihand 6">
+                <a:extLst>
+                  <a:ext uri="{FF2B5EF4-FFF2-40B4-BE49-F238E27FC236}">
+                    <a16:creationId xmlns:a16="http://schemas.microsoft.com/office/drawing/2014/main" id="{058ACE9B-A35A-6E00-D208-DD1F91CCD56D}"/>
+                  </a:ext>
+                </a:extLst>
+              </p14:cNvPr>
+              <p14:cNvContentPartPr/>
+              <p14:nvPr/>
+            </p14:nvContentPartPr>
+            <p14:xfrm>
+              <a:off x="2220000" y="2409411"/>
+              <a:ext cx="7684200" cy="966600"/>
+            </p14:xfrm>
+          </p:contentPart>
+        </mc:Choice>
+        <mc:Fallback>
+          <p:pic>
+            <p:nvPicPr>
+              <p:cNvPr id="7" name="Freihand 6">
+                <a:extLst>
+                  <a:ext uri="{FF2B5EF4-FFF2-40B4-BE49-F238E27FC236}">
+                    <a16:creationId xmlns:a16="http://schemas.microsoft.com/office/drawing/2014/main" id="{058ACE9B-A35A-6E00-D208-DD1F91CCD56D}"/>
+                  </a:ext>
+                </a:extLst>
+              </p:cNvPr>
+              <p:cNvPicPr/>
+              <p:nvPr/>
+            </p:nvPicPr>
+            <p:blipFill>
+              <a:blip r:embed="rId6"/>
+              <a:stretch>
+                <a:fillRect/>
+              </a:stretch>
+            </p:blipFill>
+            <p:spPr>
+              <a:xfrm>
+                <a:off x="2213880" y="2403291"/>
+                <a:ext cx="7696440" cy="978840"/>
+              </a:xfrm>
+              <a:prstGeom prst="rect">
+                <a:avLst/>
+              </a:prstGeom>
+            </p:spPr>
+          </p:pic>
+        </mc:Fallback>
+      </mc:AlternateContent>
+      <p:grpSp>
+        <p:nvGrpSpPr>
+          <p:cNvPr id="15" name="Gruppieren 14">
+            <a:extLst>
+              <a:ext uri="{FF2B5EF4-FFF2-40B4-BE49-F238E27FC236}">
+                <a16:creationId xmlns:a16="http://schemas.microsoft.com/office/drawing/2014/main" id="{11586CDA-89E5-4777-85EB-A4893D40ED9D}"/>
+              </a:ext>
+            </a:extLst>
+          </p:cNvPr>
+          <p:cNvGrpSpPr/>
+          <p:nvPr/>
+        </p:nvGrpSpPr>
+        <p:grpSpPr>
+          <a:xfrm>
+            <a:off x="6094680" y="3292491"/>
+            <a:ext cx="1330560" cy="1400760"/>
+            <a:chOff x="6094680" y="3292491"/>
+            <a:chExt cx="1330560" cy="1400760"/>
+          </a:xfrm>
+        </p:grpSpPr>
+        <mc:AlternateContent xmlns:mc="http://schemas.openxmlformats.org/markup-compatibility/2006">
+          <mc:Choice xmlns:p14="http://schemas.microsoft.com/office/powerpoint/2010/main" Requires="p14">
+            <p:contentPart p14:bwMode="auto" r:id="rId7">
+              <p14:nvContentPartPr>
+                <p14:cNvPr id="12" name="Freihand 11">
+                  <a:extLst>
+                    <a:ext uri="{FF2B5EF4-FFF2-40B4-BE49-F238E27FC236}">
+                      <a16:creationId xmlns:a16="http://schemas.microsoft.com/office/drawing/2014/main" id="{9BDBFE17-8503-7E51-86E5-A45B8B5BAAA2}"/>
+                    </a:ext>
+                  </a:extLst>
+                </p14:cNvPr>
+                <p14:cNvContentPartPr/>
+                <p14:nvPr/>
+              </p14:nvContentPartPr>
+              <p14:xfrm>
+                <a:off x="6111240" y="3292491"/>
+                <a:ext cx="1314000" cy="1327320"/>
+              </p14:xfrm>
+            </p:contentPart>
+          </mc:Choice>
+          <mc:Fallback>
+            <p:pic>
+              <p:nvPicPr>
+                <p:cNvPr id="12" name="Freihand 11">
+                  <a:extLst>
+                    <a:ext uri="{FF2B5EF4-FFF2-40B4-BE49-F238E27FC236}">
+                      <a16:creationId xmlns:a16="http://schemas.microsoft.com/office/drawing/2014/main" id="{9BDBFE17-8503-7E51-86E5-A45B8B5BAAA2}"/>
+                    </a:ext>
+                  </a:extLst>
+                </p:cNvPr>
+                <p:cNvPicPr/>
+                <p:nvPr/>
+              </p:nvPicPr>
+              <p:blipFill>
+                <a:blip r:embed="rId8"/>
+                <a:stretch>
+                  <a:fillRect/>
+                </a:stretch>
+              </p:blipFill>
+              <p:spPr>
+                <a:xfrm>
+                  <a:off x="6105120" y="3286371"/>
+                  <a:ext cx="1326240" cy="1339560"/>
+                </a:xfrm>
+                <a:prstGeom prst="rect">
+                  <a:avLst/>
+                </a:prstGeom>
+              </p:spPr>
+            </p:pic>
+          </mc:Fallback>
+        </mc:AlternateContent>
+        <mc:AlternateContent xmlns:mc="http://schemas.openxmlformats.org/markup-compatibility/2006">
+          <mc:Choice xmlns:p14="http://schemas.microsoft.com/office/powerpoint/2010/main" Requires="p14">
+            <p:contentPart p14:bwMode="auto" r:id="rId9">
+              <p14:nvContentPartPr>
+                <p14:cNvPr id="13" name="Freihand 12">
+                  <a:extLst>
+                    <a:ext uri="{FF2B5EF4-FFF2-40B4-BE49-F238E27FC236}">
+                      <a16:creationId xmlns:a16="http://schemas.microsoft.com/office/drawing/2014/main" id="{0F0A6743-5685-7EF1-88A2-285D2C145279}"/>
+                    </a:ext>
+                  </a:extLst>
+                </p14:cNvPr>
+                <p14:cNvContentPartPr/>
+                <p14:nvPr/>
+              </p14:nvContentPartPr>
+              <p14:xfrm>
+                <a:off x="6094680" y="4513611"/>
+                <a:ext cx="263160" cy="179640"/>
+              </p14:xfrm>
+            </p:contentPart>
+          </mc:Choice>
+          <mc:Fallback>
+            <p:pic>
+              <p:nvPicPr>
+                <p:cNvPr id="13" name="Freihand 12">
+                  <a:extLst>
+                    <a:ext uri="{FF2B5EF4-FFF2-40B4-BE49-F238E27FC236}">
+                      <a16:creationId xmlns:a16="http://schemas.microsoft.com/office/drawing/2014/main" id="{0F0A6743-5685-7EF1-88A2-285D2C145279}"/>
+                    </a:ext>
+                  </a:extLst>
+                </p:cNvPr>
+                <p:cNvPicPr/>
+                <p:nvPr/>
+              </p:nvPicPr>
+              <p:blipFill>
+                <a:blip r:embed="rId10"/>
+                <a:stretch>
+                  <a:fillRect/>
+                </a:stretch>
+              </p:blipFill>
+              <p:spPr>
+                <a:xfrm>
+                  <a:off x="6088560" y="4507491"/>
+                  <a:ext cx="275400" cy="191880"/>
+                </a:xfrm>
+                <a:prstGeom prst="rect">
+                  <a:avLst/>
+                </a:prstGeom>
+              </p:spPr>
+            </p:pic>
+          </mc:Fallback>
+        </mc:AlternateContent>
+      </p:grpSp>
+      <mc:AlternateContent xmlns:mc="http://schemas.openxmlformats.org/markup-compatibility/2006">
+        <mc:Choice xmlns:p14="http://schemas.microsoft.com/office/powerpoint/2010/main" Requires="p14">
+          <p:contentPart p14:bwMode="auto" r:id="rId11">
+            <p14:nvContentPartPr>
+              <p14:cNvPr id="16" name="Freihand 15">
+                <a:extLst>
+                  <a:ext uri="{FF2B5EF4-FFF2-40B4-BE49-F238E27FC236}">
+                    <a16:creationId xmlns:a16="http://schemas.microsoft.com/office/drawing/2014/main" id="{122C9F82-5DE9-0DFB-47ED-6C95F489E987}"/>
+                  </a:ext>
+                </a:extLst>
+              </p14:cNvPr>
+              <p14:cNvContentPartPr/>
+              <p14:nvPr/>
+            </p14:nvContentPartPr>
+            <p14:xfrm>
+              <a:off x="2077440" y="1590411"/>
+              <a:ext cx="2690280" cy="805680"/>
+            </p14:xfrm>
+          </p:contentPart>
+        </mc:Choice>
+        <mc:Fallback>
+          <p:pic>
+            <p:nvPicPr>
+              <p:cNvPr id="16" name="Freihand 15">
+                <a:extLst>
+                  <a:ext uri="{FF2B5EF4-FFF2-40B4-BE49-F238E27FC236}">
+                    <a16:creationId xmlns:a16="http://schemas.microsoft.com/office/drawing/2014/main" id="{122C9F82-5DE9-0DFB-47ED-6C95F489E987}"/>
+                  </a:ext>
+                </a:extLst>
+              </p:cNvPr>
+              <p:cNvPicPr/>
+              <p:nvPr/>
+            </p:nvPicPr>
+            <p:blipFill>
+              <a:blip r:embed="rId12"/>
+              <a:stretch>
+                <a:fillRect/>
+              </a:stretch>
+            </p:blipFill>
+            <p:spPr>
+              <a:xfrm>
+                <a:off x="2071320" y="1584291"/>
+                <a:ext cx="2702520" cy="817920"/>
+              </a:xfrm>
+              <a:prstGeom prst="rect">
+                <a:avLst/>
+              </a:prstGeom>
+            </p:spPr>
+          </p:pic>
+        </mc:Fallback>
+      </mc:AlternateContent>
+      <p:grpSp>
+        <p:nvGrpSpPr>
+          <p:cNvPr id="29" name="Gruppieren 28">
+            <a:extLst>
+              <a:ext uri="{FF2B5EF4-FFF2-40B4-BE49-F238E27FC236}">
+                <a16:creationId xmlns:a16="http://schemas.microsoft.com/office/drawing/2014/main" id="{07A4A003-93D2-2A3E-B743-805F73332D3D}"/>
+              </a:ext>
+            </a:extLst>
+          </p:cNvPr>
+          <p:cNvGrpSpPr/>
+          <p:nvPr/>
+        </p:nvGrpSpPr>
+        <p:grpSpPr>
+          <a:xfrm>
+            <a:off x="4760520" y="874011"/>
+            <a:ext cx="2495880" cy="974160"/>
+            <a:chOff x="4760520" y="874011"/>
+            <a:chExt cx="2495880" cy="974160"/>
+          </a:xfrm>
+        </p:grpSpPr>
+        <mc:AlternateContent xmlns:mc="http://schemas.openxmlformats.org/markup-compatibility/2006">
+          <mc:Choice xmlns:p14="http://schemas.microsoft.com/office/powerpoint/2010/main" Requires="p14">
+            <p:contentPart p14:bwMode="auto" r:id="rId13">
+              <p14:nvContentPartPr>
+                <p14:cNvPr id="17" name="Freihand 16">
+                  <a:extLst>
+                    <a:ext uri="{FF2B5EF4-FFF2-40B4-BE49-F238E27FC236}">
+                      <a16:creationId xmlns:a16="http://schemas.microsoft.com/office/drawing/2014/main" id="{0FA0F1C5-790B-9C21-E90C-59E9E6BDA513}"/>
+                    </a:ext>
+                  </a:extLst>
+                </p14:cNvPr>
+                <p14:cNvContentPartPr/>
+                <p14:nvPr/>
+              </p14:nvContentPartPr>
+              <p14:xfrm>
+                <a:off x="4760520" y="892731"/>
+                <a:ext cx="1241640" cy="955440"/>
+              </p14:xfrm>
+            </p:contentPart>
+          </mc:Choice>
+          <mc:Fallback>
+            <p:pic>
+              <p:nvPicPr>
+                <p:cNvPr id="17" name="Freihand 16">
+                  <a:extLst>
+                    <a:ext uri="{FF2B5EF4-FFF2-40B4-BE49-F238E27FC236}">
+                      <a16:creationId xmlns:a16="http://schemas.microsoft.com/office/drawing/2014/main" id="{0FA0F1C5-790B-9C21-E90C-59E9E6BDA513}"/>
+                    </a:ext>
+                  </a:extLst>
+                </p:cNvPr>
+                <p:cNvPicPr/>
+                <p:nvPr/>
+              </p:nvPicPr>
+              <p:blipFill>
+                <a:blip r:embed="rId14"/>
+                <a:stretch>
+                  <a:fillRect/>
+                </a:stretch>
+              </p:blipFill>
+              <p:spPr>
+                <a:xfrm>
+                  <a:off x="4754400" y="886611"/>
+                  <a:ext cx="1253880" cy="967680"/>
+                </a:xfrm>
+                <a:prstGeom prst="rect">
+                  <a:avLst/>
+                </a:prstGeom>
+              </p:spPr>
+            </p:pic>
+          </mc:Fallback>
+        </mc:AlternateContent>
+        <mc:AlternateContent xmlns:mc="http://schemas.openxmlformats.org/markup-compatibility/2006">
+          <mc:Choice xmlns:p14="http://schemas.microsoft.com/office/powerpoint/2010/main" Requires="p14">
+            <p:contentPart p14:bwMode="auto" r:id="rId15">
+              <p14:nvContentPartPr>
+                <p14:cNvPr id="18" name="Freihand 17">
+                  <a:extLst>
+                    <a:ext uri="{FF2B5EF4-FFF2-40B4-BE49-F238E27FC236}">
+                      <a16:creationId xmlns:a16="http://schemas.microsoft.com/office/drawing/2014/main" id="{808F118D-DE2C-B80F-C9FE-D03B7620B656}"/>
+                    </a:ext>
+                  </a:extLst>
+                </p14:cNvPr>
+                <p14:cNvContentPartPr/>
+                <p14:nvPr/>
+              </p14:nvContentPartPr>
+              <p14:xfrm>
+                <a:off x="6073440" y="930891"/>
+                <a:ext cx="342720" cy="3600"/>
+              </p14:xfrm>
+            </p:contentPart>
+          </mc:Choice>
+          <mc:Fallback>
+            <p:pic>
+              <p:nvPicPr>
+                <p:cNvPr id="18" name="Freihand 17">
+                  <a:extLst>
+                    <a:ext uri="{FF2B5EF4-FFF2-40B4-BE49-F238E27FC236}">
+                      <a16:creationId xmlns:a16="http://schemas.microsoft.com/office/drawing/2014/main" id="{808F118D-DE2C-B80F-C9FE-D03B7620B656}"/>
+                    </a:ext>
+                  </a:extLst>
+                </p:cNvPr>
+                <p:cNvPicPr/>
+                <p:nvPr/>
+              </p:nvPicPr>
+              <p:blipFill>
+                <a:blip r:embed="rId16"/>
+                <a:stretch>
+                  <a:fillRect/>
+                </a:stretch>
+              </p:blipFill>
+              <p:spPr>
+                <a:xfrm>
+                  <a:off x="6067320" y="924771"/>
+                  <a:ext cx="354960" cy="15840"/>
+                </a:xfrm>
+                <a:prstGeom prst="rect">
+                  <a:avLst/>
+                </a:prstGeom>
+              </p:spPr>
+            </p:pic>
+          </mc:Fallback>
+        </mc:AlternateContent>
+        <mc:AlternateContent xmlns:mc="http://schemas.openxmlformats.org/markup-compatibility/2006">
+          <mc:Choice xmlns:p14="http://schemas.microsoft.com/office/powerpoint/2010/main" Requires="p14">
+            <p:contentPart p14:bwMode="auto" r:id="rId17">
+              <p14:nvContentPartPr>
+                <p14:cNvPr id="21" name="Freihand 20">
+                  <a:extLst>
+                    <a:ext uri="{FF2B5EF4-FFF2-40B4-BE49-F238E27FC236}">
+                      <a16:creationId xmlns:a16="http://schemas.microsoft.com/office/drawing/2014/main" id="{4EC25E7E-3E5D-187D-97D5-80D47233636F}"/>
+                    </a:ext>
+                  </a:extLst>
+                </p14:cNvPr>
+                <p14:cNvContentPartPr/>
+                <p14:nvPr/>
+              </p14:nvContentPartPr>
+              <p14:xfrm>
+                <a:off x="6741240" y="922971"/>
+                <a:ext cx="515160" cy="28080"/>
+              </p14:xfrm>
+            </p:contentPart>
+          </mc:Choice>
+          <mc:Fallback>
+            <p:pic>
+              <p:nvPicPr>
+                <p:cNvPr id="21" name="Freihand 20">
+                  <a:extLst>
+                    <a:ext uri="{FF2B5EF4-FFF2-40B4-BE49-F238E27FC236}">
+                      <a16:creationId xmlns:a16="http://schemas.microsoft.com/office/drawing/2014/main" id="{4EC25E7E-3E5D-187D-97D5-80D47233636F}"/>
+                    </a:ext>
+                  </a:extLst>
+                </p:cNvPr>
+                <p:cNvPicPr/>
+                <p:nvPr/>
+              </p:nvPicPr>
+              <p:blipFill>
+                <a:blip r:embed="rId18"/>
+                <a:stretch>
+                  <a:fillRect/>
+                </a:stretch>
+              </p:blipFill>
+              <p:spPr>
+                <a:xfrm>
+                  <a:off x="6735120" y="916851"/>
+                  <a:ext cx="527400" cy="40320"/>
+                </a:xfrm>
+                <a:prstGeom prst="rect">
+                  <a:avLst/>
+                </a:prstGeom>
+              </p:spPr>
+            </p:pic>
+          </mc:Fallback>
+        </mc:AlternateContent>
+        <mc:AlternateContent xmlns:mc="http://schemas.openxmlformats.org/markup-compatibility/2006">
+          <mc:Choice xmlns:p14="http://schemas.microsoft.com/office/powerpoint/2010/main" Requires="p14">
+            <p:contentPart p14:bwMode="auto" r:id="rId19">
+              <p14:nvContentPartPr>
+                <p14:cNvPr id="24" name="Freihand 23">
+                  <a:extLst>
+                    <a:ext uri="{FF2B5EF4-FFF2-40B4-BE49-F238E27FC236}">
+                      <a16:creationId xmlns:a16="http://schemas.microsoft.com/office/drawing/2014/main" id="{EECD7C6E-7DA6-8560-BA4D-C6F544241447}"/>
+                    </a:ext>
+                  </a:extLst>
+                </p14:cNvPr>
+                <p14:cNvContentPartPr/>
+                <p14:nvPr/>
+              </p14:nvContentPartPr>
+              <p14:xfrm>
+                <a:off x="5894880" y="874011"/>
+                <a:ext cx="102600" cy="145440"/>
+              </p14:xfrm>
+            </p:contentPart>
+          </mc:Choice>
+          <mc:Fallback>
+            <p:pic>
+              <p:nvPicPr>
+                <p:cNvPr id="24" name="Freihand 23">
+                  <a:extLst>
+                    <a:ext uri="{FF2B5EF4-FFF2-40B4-BE49-F238E27FC236}">
+                      <a16:creationId xmlns:a16="http://schemas.microsoft.com/office/drawing/2014/main" id="{EECD7C6E-7DA6-8560-BA4D-C6F544241447}"/>
+                    </a:ext>
+                  </a:extLst>
+                </p:cNvPr>
+                <p:cNvPicPr/>
+                <p:nvPr/>
+              </p:nvPicPr>
+              <p:blipFill>
+                <a:blip r:embed="rId20"/>
+                <a:stretch>
+                  <a:fillRect/>
+                </a:stretch>
+              </p:blipFill>
+              <p:spPr>
+                <a:xfrm>
+                  <a:off x="5888760" y="867891"/>
+                  <a:ext cx="114840" cy="157680"/>
+                </a:xfrm>
+                <a:prstGeom prst="rect">
+                  <a:avLst/>
+                </a:prstGeom>
+              </p:spPr>
+            </p:pic>
+          </mc:Fallback>
+        </mc:AlternateContent>
+        <mc:AlternateContent xmlns:mc="http://schemas.openxmlformats.org/markup-compatibility/2006">
+          <mc:Choice xmlns:p14="http://schemas.microsoft.com/office/powerpoint/2010/main" Requires="p14">
+            <p:contentPart p14:bwMode="auto" r:id="rId21">
+              <p14:nvContentPartPr>
+                <p14:cNvPr id="27" name="Freihand 26">
+                  <a:extLst>
+                    <a:ext uri="{FF2B5EF4-FFF2-40B4-BE49-F238E27FC236}">
+                      <a16:creationId xmlns:a16="http://schemas.microsoft.com/office/drawing/2014/main" id="{9B3D0934-9E9B-F847-72A1-9D4BCEC54285}"/>
+                    </a:ext>
+                  </a:extLst>
+                </p14:cNvPr>
+                <p14:cNvContentPartPr/>
+                <p14:nvPr/>
+              </p14:nvContentPartPr>
+              <p14:xfrm>
+                <a:off x="6416520" y="936291"/>
+                <a:ext cx="121320" cy="6480"/>
+              </p14:xfrm>
+            </p:contentPart>
+          </mc:Choice>
+          <mc:Fallback>
+            <p:pic>
+              <p:nvPicPr>
+                <p:cNvPr id="27" name="Freihand 26">
+                  <a:extLst>
+                    <a:ext uri="{FF2B5EF4-FFF2-40B4-BE49-F238E27FC236}">
+                      <a16:creationId xmlns:a16="http://schemas.microsoft.com/office/drawing/2014/main" id="{9B3D0934-9E9B-F847-72A1-9D4BCEC54285}"/>
+                    </a:ext>
+                  </a:extLst>
+                </p:cNvPr>
+                <p:cNvPicPr/>
+                <p:nvPr/>
+              </p:nvPicPr>
+              <p:blipFill>
+                <a:blip r:embed="rId22"/>
+                <a:stretch>
+                  <a:fillRect/>
+                </a:stretch>
+              </p:blipFill>
+              <p:spPr>
+                <a:xfrm>
+                  <a:off x="6410400" y="930171"/>
+                  <a:ext cx="133560" cy="18720"/>
+                </a:xfrm>
+                <a:prstGeom prst="rect">
+                  <a:avLst/>
+                </a:prstGeom>
+              </p:spPr>
+            </p:pic>
+          </mc:Fallback>
+        </mc:AlternateContent>
+      </p:grpSp>
+      <p:sp>
+        <p:nvSpPr>
+          <p:cNvPr id="30" name="Textfeld 29">
+            <a:extLst>
+              <a:ext uri="{FF2B5EF4-FFF2-40B4-BE49-F238E27FC236}">
+                <a16:creationId xmlns:a16="http://schemas.microsoft.com/office/drawing/2014/main" id="{015B81BD-D1A1-F4E6-4787-86210CDEF2B1}"/>
+              </a:ext>
+            </a:extLst>
+          </p:cNvPr>
+          <p:cNvSpPr txBox="1"/>
+          <p:nvPr/>
+        </p:nvSpPr>
+        <p:spPr>
+          <a:xfrm>
+            <a:off x="10111675" y="2708045"/>
+            <a:ext cx="1285929" cy="369332"/>
+          </a:xfrm>
+          <a:prstGeom prst="rect">
+            <a:avLst/>
+          </a:prstGeom>
+          <a:noFill/>
+        </p:spPr>
+        <p:txBody>
+          <a:bodyPr wrap="none" rtlCol="0">
+            <a:spAutoFit/>
+          </a:bodyPr>
+          <a:lstStyle/>
+          <a:p>
+            <a:r>
+              <a:rPr lang="de-DE" dirty="0">
+                <a:solidFill>
+                  <a:srgbClr val="FF0000"/>
+                </a:solidFill>
+              </a:rPr>
+              <a:t>Redundant</a:t>
+            </a:r>
+          </a:p>
+        </p:txBody>
+      </p:sp>
+      <p:sp>
+        <p:nvSpPr>
+          <p:cNvPr id="31" name="Textfeld 30">
+            <a:extLst>
+              <a:ext uri="{FF2B5EF4-FFF2-40B4-BE49-F238E27FC236}">
+                <a16:creationId xmlns:a16="http://schemas.microsoft.com/office/drawing/2014/main" id="{831A30C8-AD85-D4EE-A4F5-95E4133011F2}"/>
+              </a:ext>
+            </a:extLst>
+          </p:cNvPr>
+          <p:cNvSpPr txBox="1"/>
+          <p:nvPr/>
+        </p:nvSpPr>
+        <p:spPr>
+          <a:xfrm>
+            <a:off x="3533596" y="329373"/>
+            <a:ext cx="1285929" cy="369332"/>
+          </a:xfrm>
+          <a:prstGeom prst="rect">
+            <a:avLst/>
+          </a:prstGeom>
+          <a:noFill/>
+        </p:spPr>
+        <p:txBody>
+          <a:bodyPr wrap="none" rtlCol="0">
+            <a:spAutoFit/>
+          </a:bodyPr>
+          <a:lstStyle/>
+          <a:p>
+            <a:r>
+              <a:rPr lang="de-DE" dirty="0">
+                <a:solidFill>
+                  <a:srgbClr val="FF0000"/>
+                </a:solidFill>
+              </a:rPr>
+              <a:t>Redundant</a:t>
+            </a:r>
+          </a:p>
+        </p:txBody>
+      </p:sp>
+      <mc:AlternateContent xmlns:mc="http://schemas.openxmlformats.org/markup-compatibility/2006">
+        <mc:Choice xmlns:p14="http://schemas.microsoft.com/office/powerpoint/2010/main" Requires="p14">
+          <p:contentPart p14:bwMode="auto" r:id="rId23">
+            <p14:nvContentPartPr>
+              <p14:cNvPr id="32" name="Freihand 31">
+                <a:extLst>
+                  <a:ext uri="{FF2B5EF4-FFF2-40B4-BE49-F238E27FC236}">
+                    <a16:creationId xmlns:a16="http://schemas.microsoft.com/office/drawing/2014/main" id="{8F9BAA2F-5C29-A2FE-19E9-2AB4237E6E34}"/>
+                  </a:ext>
+                </a:extLst>
+              </p14:cNvPr>
+              <p14:cNvContentPartPr/>
+              <p14:nvPr/>
+            </p14:nvContentPartPr>
+            <p14:xfrm>
+              <a:off x="3495480" y="816411"/>
+              <a:ext cx="706680" cy="245520"/>
+            </p14:xfrm>
+          </p:contentPart>
+        </mc:Choice>
+        <mc:Fallback>
+          <p:pic>
+            <p:nvPicPr>
+              <p:cNvPr id="32" name="Freihand 31">
+                <a:extLst>
+                  <a:ext uri="{FF2B5EF4-FFF2-40B4-BE49-F238E27FC236}">
+                    <a16:creationId xmlns:a16="http://schemas.microsoft.com/office/drawing/2014/main" id="{8F9BAA2F-5C29-A2FE-19E9-2AB4237E6E34}"/>
+                  </a:ext>
+                </a:extLst>
+              </p:cNvPr>
+              <p:cNvPicPr/>
+              <p:nvPr/>
+            </p:nvPicPr>
+            <p:blipFill>
+              <a:blip r:embed="rId24"/>
+              <a:stretch>
+                <a:fillRect/>
+              </a:stretch>
+            </p:blipFill>
+            <p:spPr>
+              <a:xfrm>
+                <a:off x="3489360" y="810291"/>
+                <a:ext cx="718920" cy="257760"/>
+              </a:xfrm>
+              <a:prstGeom prst="rect">
+                <a:avLst/>
+              </a:prstGeom>
+            </p:spPr>
+          </p:pic>
+        </mc:Fallback>
+      </mc:AlternateContent>
+      <mc:AlternateContent xmlns:mc="http://schemas.openxmlformats.org/markup-compatibility/2006">
+        <mc:Choice xmlns:p14="http://schemas.microsoft.com/office/powerpoint/2010/main" Requires="p14">
+          <p:contentPart p14:bwMode="auto" r:id="rId25">
+            <p14:nvContentPartPr>
+              <p14:cNvPr id="33" name="Freihand 32">
+                <a:extLst>
+                  <a:ext uri="{FF2B5EF4-FFF2-40B4-BE49-F238E27FC236}">
+                    <a16:creationId xmlns:a16="http://schemas.microsoft.com/office/drawing/2014/main" id="{E63F9068-16C2-22C2-B85A-E19996233444}"/>
+                  </a:ext>
+                </a:extLst>
+              </p14:cNvPr>
+              <p14:cNvContentPartPr/>
+              <p14:nvPr/>
+            </p14:nvContentPartPr>
+            <p14:xfrm>
+              <a:off x="3894000" y="2604891"/>
+              <a:ext cx="3533760" cy="581040"/>
+            </p14:xfrm>
+          </p:contentPart>
+        </mc:Choice>
+        <mc:Fallback>
+          <p:pic>
+            <p:nvPicPr>
+              <p:cNvPr id="33" name="Freihand 32">
+                <a:extLst>
+                  <a:ext uri="{FF2B5EF4-FFF2-40B4-BE49-F238E27FC236}">
+                    <a16:creationId xmlns:a16="http://schemas.microsoft.com/office/drawing/2014/main" id="{E63F9068-16C2-22C2-B85A-E19996233444}"/>
+                  </a:ext>
+                </a:extLst>
+              </p:cNvPr>
+              <p:cNvPicPr/>
+              <p:nvPr/>
+            </p:nvPicPr>
+            <p:blipFill>
+              <a:blip r:embed="rId26"/>
+              <a:stretch>
+                <a:fillRect/>
+              </a:stretch>
+            </p:blipFill>
+            <p:spPr>
+              <a:xfrm>
+                <a:off x="3887880" y="2598771"/>
+                <a:ext cx="3546000" cy="593280"/>
+              </a:xfrm>
+              <a:prstGeom prst="rect">
+                <a:avLst/>
+              </a:prstGeom>
+            </p:spPr>
+          </p:pic>
+        </mc:Fallback>
+      </mc:AlternateContent>
+      <p:sp>
+        <p:nvSpPr>
+          <p:cNvPr id="34" name="Textfeld 33">
+            <a:extLst>
+              <a:ext uri="{FF2B5EF4-FFF2-40B4-BE49-F238E27FC236}">
+                <a16:creationId xmlns:a16="http://schemas.microsoft.com/office/drawing/2014/main" id="{C2EB9CBB-1A36-2814-542C-0F45C6B7E840}"/>
+              </a:ext>
+            </a:extLst>
+          </p:cNvPr>
+          <p:cNvSpPr txBox="1"/>
+          <p:nvPr/>
+        </p:nvSpPr>
+        <p:spPr>
+          <a:xfrm>
+            <a:off x="4880419" y="1711039"/>
+            <a:ext cx="3071482" cy="369332"/>
+          </a:xfrm>
+          <a:prstGeom prst="rect">
+            <a:avLst/>
+          </a:prstGeom>
+          <a:noFill/>
+        </p:spPr>
+        <p:txBody>
+          <a:bodyPr wrap="none" rtlCol="0">
+            <a:spAutoFit/>
+          </a:bodyPr>
+          <a:lstStyle/>
+          <a:p>
+            <a:r>
+              <a:rPr lang="de-DE" dirty="0">
+                <a:solidFill>
+                  <a:srgbClr val="FF0000"/>
+                </a:solidFill>
+              </a:rPr>
+              <a:t>verschieben in die </a:t>
+            </a:r>
+            <a:r>
+              <a:rPr lang="de-DE" dirty="0" err="1">
+                <a:solidFill>
+                  <a:srgbClr val="FF0000"/>
+                </a:solidFill>
+              </a:rPr>
+              <a:t>Navileiste</a:t>
+            </a:r>
+            <a:endParaRPr lang="de-DE" dirty="0">
+              <a:solidFill>
+                <a:srgbClr val="FF0000"/>
+              </a:solidFill>
+            </a:endParaRPr>
+          </a:p>
+        </p:txBody>
+      </p:sp>
+      <p:sp>
+        <p:nvSpPr>
+          <p:cNvPr id="35" name="Textfeld 34">
+            <a:extLst>
+              <a:ext uri="{FF2B5EF4-FFF2-40B4-BE49-F238E27FC236}">
+                <a16:creationId xmlns:a16="http://schemas.microsoft.com/office/drawing/2014/main" id="{DBB4320D-3A75-31EA-9C1C-F0AAC831560A}"/>
+              </a:ext>
+            </a:extLst>
+          </p:cNvPr>
+          <p:cNvSpPr txBox="1"/>
+          <p:nvPr/>
+        </p:nvSpPr>
+        <p:spPr>
+          <a:xfrm>
+            <a:off x="96115" y="4807845"/>
+            <a:ext cx="2189895" cy="646331"/>
+          </a:xfrm>
+          <a:prstGeom prst="rect">
+            <a:avLst/>
+          </a:prstGeom>
+          <a:noFill/>
+        </p:spPr>
+        <p:txBody>
+          <a:bodyPr wrap="none" rtlCol="0">
+            <a:spAutoFit/>
+          </a:bodyPr>
+          <a:lstStyle/>
+          <a:p>
+            <a:r>
+              <a:rPr lang="de-DE" dirty="0">
+                <a:solidFill>
+                  <a:srgbClr val="FF0000"/>
+                </a:solidFill>
+              </a:rPr>
+              <a:t>Klareres Schriftbild, </a:t>
+            </a:r>
+          </a:p>
+          <a:p>
+            <a:r>
+              <a:rPr lang="de-DE" dirty="0">
+                <a:solidFill>
+                  <a:srgbClr val="FF0000"/>
+                </a:solidFill>
+              </a:rPr>
+              <a:t>mehr Kontrast</a:t>
+            </a:r>
+          </a:p>
+        </p:txBody>
+      </p:sp>
+      <p:grpSp>
+        <p:nvGrpSpPr>
+          <p:cNvPr id="40" name="Gruppieren 39">
+            <a:extLst>
+              <a:ext uri="{FF2B5EF4-FFF2-40B4-BE49-F238E27FC236}">
+                <a16:creationId xmlns:a16="http://schemas.microsoft.com/office/drawing/2014/main" id="{8F567D13-1714-7CB6-965C-973851E843B6}"/>
+              </a:ext>
+            </a:extLst>
+          </p:cNvPr>
+          <p:cNvGrpSpPr/>
+          <p:nvPr/>
+        </p:nvGrpSpPr>
+        <p:grpSpPr>
+          <a:xfrm>
+            <a:off x="728880" y="1066971"/>
+            <a:ext cx="2544120" cy="3726360"/>
+            <a:chOff x="728880" y="1066971"/>
+            <a:chExt cx="2544120" cy="3726360"/>
+          </a:xfrm>
+        </p:grpSpPr>
+        <mc:AlternateContent xmlns:mc="http://schemas.openxmlformats.org/markup-compatibility/2006">
+          <mc:Choice xmlns:p14="http://schemas.microsoft.com/office/powerpoint/2010/main" Requires="p14">
+            <p:contentPart p14:bwMode="auto" r:id="rId27">
+              <p14:nvContentPartPr>
+                <p14:cNvPr id="8" name="Freihand 7">
+                  <a:extLst>
+                    <a:ext uri="{FF2B5EF4-FFF2-40B4-BE49-F238E27FC236}">
+                      <a16:creationId xmlns:a16="http://schemas.microsoft.com/office/drawing/2014/main" id="{8F52BC89-B3F8-842D-CF55-971DC8F8F20C}"/>
+                    </a:ext>
+                  </a:extLst>
+                </p14:cNvPr>
+                <p14:cNvContentPartPr/>
+                <p14:nvPr/>
+              </p14:nvContentPartPr>
+              <p14:xfrm>
+                <a:off x="1437360" y="1066971"/>
+                <a:ext cx="1835640" cy="3495240"/>
+              </p14:xfrm>
+            </p:contentPart>
+          </mc:Choice>
+          <mc:Fallback>
+            <p:pic>
+              <p:nvPicPr>
+                <p:cNvPr id="8" name="Freihand 7">
+                  <a:extLst>
+                    <a:ext uri="{FF2B5EF4-FFF2-40B4-BE49-F238E27FC236}">
+                      <a16:creationId xmlns:a16="http://schemas.microsoft.com/office/drawing/2014/main" id="{8F52BC89-B3F8-842D-CF55-971DC8F8F20C}"/>
+                    </a:ext>
+                  </a:extLst>
+                </p:cNvPr>
+                <p:cNvPicPr/>
+                <p:nvPr/>
+              </p:nvPicPr>
+              <p:blipFill>
+                <a:blip r:embed="rId28"/>
+                <a:stretch>
+                  <a:fillRect/>
+                </a:stretch>
+              </p:blipFill>
+              <p:spPr>
+                <a:xfrm>
+                  <a:off x="1431240" y="1060851"/>
+                  <a:ext cx="1847880" cy="3507480"/>
+                </a:xfrm>
+                <a:prstGeom prst="rect">
+                  <a:avLst/>
+                </a:prstGeom>
+              </p:spPr>
+            </p:pic>
+          </mc:Fallback>
+        </mc:AlternateContent>
+        <mc:AlternateContent xmlns:mc="http://schemas.openxmlformats.org/markup-compatibility/2006">
+          <mc:Choice xmlns:p14="http://schemas.microsoft.com/office/powerpoint/2010/main" Requires="p14">
+            <p:contentPart p14:bwMode="auto" r:id="rId29">
+              <p14:nvContentPartPr>
+                <p14:cNvPr id="9" name="Freihand 8">
+                  <a:extLst>
+                    <a:ext uri="{FF2B5EF4-FFF2-40B4-BE49-F238E27FC236}">
+                      <a16:creationId xmlns:a16="http://schemas.microsoft.com/office/drawing/2014/main" id="{C5A3652F-41EE-5E01-35C5-B916483004E4}"/>
+                    </a:ext>
+                  </a:extLst>
+                </p14:cNvPr>
+                <p14:cNvContentPartPr/>
+                <p14:nvPr/>
+              </p14:nvContentPartPr>
+              <p14:xfrm>
+                <a:off x="2123160" y="4383291"/>
+                <a:ext cx="280440" cy="236520"/>
+              </p14:xfrm>
+            </p:contentPart>
+          </mc:Choice>
+          <mc:Fallback>
+            <p:pic>
+              <p:nvPicPr>
+                <p:cNvPr id="9" name="Freihand 8">
+                  <a:extLst>
+                    <a:ext uri="{FF2B5EF4-FFF2-40B4-BE49-F238E27FC236}">
+                      <a16:creationId xmlns:a16="http://schemas.microsoft.com/office/drawing/2014/main" id="{C5A3652F-41EE-5E01-35C5-B916483004E4}"/>
+                    </a:ext>
+                  </a:extLst>
+                </p:cNvPr>
+                <p:cNvPicPr/>
+                <p:nvPr/>
+              </p:nvPicPr>
+              <p:blipFill>
+                <a:blip r:embed="rId30"/>
+                <a:stretch>
+                  <a:fillRect/>
+                </a:stretch>
+              </p:blipFill>
+              <p:spPr>
+                <a:xfrm>
+                  <a:off x="2117040" y="4377171"/>
+                  <a:ext cx="292680" cy="248760"/>
+                </a:xfrm>
+                <a:prstGeom prst="rect">
+                  <a:avLst/>
+                </a:prstGeom>
+              </p:spPr>
+            </p:pic>
+          </mc:Fallback>
+        </mc:AlternateContent>
+        <mc:AlternateContent xmlns:mc="http://schemas.openxmlformats.org/markup-compatibility/2006">
+          <mc:Choice xmlns:p14="http://schemas.microsoft.com/office/powerpoint/2010/main" Requires="p14">
+            <p:contentPart p14:bwMode="auto" r:id="rId31">
+              <p14:nvContentPartPr>
+                <p14:cNvPr id="36" name="Freihand 35">
+                  <a:extLst>
+                    <a:ext uri="{FF2B5EF4-FFF2-40B4-BE49-F238E27FC236}">
+                      <a16:creationId xmlns:a16="http://schemas.microsoft.com/office/drawing/2014/main" id="{45F60C55-A0C8-99E9-555F-D09B1E0814DC}"/>
+                    </a:ext>
+                  </a:extLst>
+                </p14:cNvPr>
+                <p14:cNvContentPartPr/>
+                <p14:nvPr/>
+              </p14:nvContentPartPr>
+              <p14:xfrm>
+                <a:off x="728880" y="3818091"/>
+                <a:ext cx="1785240" cy="975240"/>
+              </p14:xfrm>
+            </p:contentPart>
+          </mc:Choice>
+          <mc:Fallback>
+            <p:pic>
+              <p:nvPicPr>
+                <p:cNvPr id="36" name="Freihand 35">
+                  <a:extLst>
+                    <a:ext uri="{FF2B5EF4-FFF2-40B4-BE49-F238E27FC236}">
+                      <a16:creationId xmlns:a16="http://schemas.microsoft.com/office/drawing/2014/main" id="{45F60C55-A0C8-99E9-555F-D09B1E0814DC}"/>
+                    </a:ext>
+                  </a:extLst>
+                </p:cNvPr>
+                <p:cNvPicPr/>
+                <p:nvPr/>
+              </p:nvPicPr>
+              <p:blipFill>
+                <a:blip r:embed="rId32"/>
+                <a:stretch>
+                  <a:fillRect/>
+                </a:stretch>
+              </p:blipFill>
+              <p:spPr>
+                <a:xfrm>
+                  <a:off x="722760" y="3811971"/>
+                  <a:ext cx="1797480" cy="987480"/>
+                </a:xfrm>
+                <a:prstGeom prst="rect">
+                  <a:avLst/>
+                </a:prstGeom>
+              </p:spPr>
+            </p:pic>
+          </mc:Fallback>
+        </mc:AlternateContent>
+        <mc:AlternateContent xmlns:mc="http://schemas.openxmlformats.org/markup-compatibility/2006">
+          <mc:Choice xmlns:p14="http://schemas.microsoft.com/office/powerpoint/2010/main" Requires="p14">
+            <p:contentPart p14:bwMode="auto" r:id="rId33">
+              <p14:nvContentPartPr>
+                <p14:cNvPr id="37" name="Freihand 36">
+                  <a:extLst>
+                    <a:ext uri="{FF2B5EF4-FFF2-40B4-BE49-F238E27FC236}">
+                      <a16:creationId xmlns:a16="http://schemas.microsoft.com/office/drawing/2014/main" id="{DF3A10C2-4520-51A9-1DCC-9B99B25E3688}"/>
+                    </a:ext>
+                  </a:extLst>
+                </p14:cNvPr>
+                <p14:cNvContentPartPr/>
+                <p14:nvPr/>
+              </p14:nvContentPartPr>
+              <p14:xfrm>
+                <a:off x="2263200" y="3801891"/>
+                <a:ext cx="251280" cy="25920"/>
+              </p14:xfrm>
+            </p:contentPart>
+          </mc:Choice>
+          <mc:Fallback>
+            <p:pic>
+              <p:nvPicPr>
+                <p:cNvPr id="37" name="Freihand 36">
+                  <a:extLst>
+                    <a:ext uri="{FF2B5EF4-FFF2-40B4-BE49-F238E27FC236}">
+                      <a16:creationId xmlns:a16="http://schemas.microsoft.com/office/drawing/2014/main" id="{DF3A10C2-4520-51A9-1DCC-9B99B25E3688}"/>
+                    </a:ext>
+                  </a:extLst>
+                </p:cNvPr>
+                <p:cNvPicPr/>
+                <p:nvPr/>
+              </p:nvPicPr>
+              <p:blipFill>
+                <a:blip r:embed="rId34"/>
+                <a:stretch>
+                  <a:fillRect/>
+                </a:stretch>
+              </p:blipFill>
+              <p:spPr>
+                <a:xfrm>
+                  <a:off x="2257080" y="3795771"/>
+                  <a:ext cx="263520" cy="38160"/>
+                </a:xfrm>
+                <a:prstGeom prst="rect">
+                  <a:avLst/>
+                </a:prstGeom>
+              </p:spPr>
+            </p:pic>
+          </mc:Fallback>
+        </mc:AlternateContent>
+        <mc:AlternateContent xmlns:mc="http://schemas.openxmlformats.org/markup-compatibility/2006">
+          <mc:Choice xmlns:p14="http://schemas.microsoft.com/office/powerpoint/2010/main" Requires="p14">
+            <p:contentPart p14:bwMode="auto" r:id="rId35">
+              <p14:nvContentPartPr>
+                <p14:cNvPr id="38" name="Freihand 37">
+                  <a:extLst>
+                    <a:ext uri="{FF2B5EF4-FFF2-40B4-BE49-F238E27FC236}">
+                      <a16:creationId xmlns:a16="http://schemas.microsoft.com/office/drawing/2014/main" id="{2EB90308-2AD5-8FA2-6116-BF693093B8AE}"/>
+                    </a:ext>
+                  </a:extLst>
+                </p14:cNvPr>
+                <p14:cNvContentPartPr/>
+                <p14:nvPr/>
+              </p14:nvContentPartPr>
+              <p14:xfrm>
+                <a:off x="2327280" y="3835371"/>
+                <a:ext cx="172800" cy="84240"/>
+              </p14:xfrm>
+            </p:contentPart>
+          </mc:Choice>
+          <mc:Fallback>
+            <p:pic>
+              <p:nvPicPr>
+                <p:cNvPr id="38" name="Freihand 37">
+                  <a:extLst>
+                    <a:ext uri="{FF2B5EF4-FFF2-40B4-BE49-F238E27FC236}">
+                      <a16:creationId xmlns:a16="http://schemas.microsoft.com/office/drawing/2014/main" id="{2EB90308-2AD5-8FA2-6116-BF693093B8AE}"/>
+                    </a:ext>
+                  </a:extLst>
+                </p:cNvPr>
+                <p:cNvPicPr/>
+                <p:nvPr/>
+              </p:nvPicPr>
+              <p:blipFill>
+                <a:blip r:embed="rId36"/>
+                <a:stretch>
+                  <a:fillRect/>
+                </a:stretch>
+              </p:blipFill>
+              <p:spPr>
+                <a:xfrm>
+                  <a:off x="2321160" y="3829251"/>
+                  <a:ext cx="185040" cy="96480"/>
+                </a:xfrm>
+                <a:prstGeom prst="rect">
+                  <a:avLst/>
+                </a:prstGeom>
+              </p:spPr>
+            </p:pic>
+          </mc:Fallback>
+        </mc:AlternateContent>
+      </p:grpSp>
     </p:spTree>
     <p:extLst>
       <p:ext uri="{BB962C8B-B14F-4D97-AF65-F5344CB8AC3E}">
         <p14:creationId xmlns:p14="http://schemas.microsoft.com/office/powerpoint/2010/main" val="4275433604"/>
+      </p:ext>
+    </p:extLst>
+  </p:cSld>
+  <p:clrMapOvr>
+    <a:masterClrMapping/>
+  </p:clrMapOvr>
+</p:sld>
+</file>
+
+<file path=ppt/slides/slide2.xml><?xml version="1.0" encoding="utf-8"?>
+<p:sld xmlns:a="http://schemas.openxmlformats.org/drawingml/2006/main" xmlns:r="http://schemas.openxmlformats.org/officeDocument/2006/relationships" xmlns:p="http://schemas.openxmlformats.org/presentationml/2006/main">
+  <p:cSld>
+    <p:spTree>
+      <p:nvGrpSpPr>
+        <p:cNvPr id="1" name=""/>
+        <p:cNvGrpSpPr/>
+        <p:nvPr/>
+      </p:nvGrpSpPr>
+      <p:grpSpPr>
+        <a:xfrm>
+          <a:off x="0" y="0"/>
+          <a:ext cx="0" cy="0"/>
+          <a:chOff x="0" y="0"/>
+          <a:chExt cx="0" cy="0"/>
+        </a:xfrm>
+      </p:grpSpPr>
+      <p:pic>
+        <p:nvPicPr>
+          <p:cNvPr id="2" name="Grafik 1">
+            <a:extLst>
+              <a:ext uri="{FF2B5EF4-FFF2-40B4-BE49-F238E27FC236}">
+                <a16:creationId xmlns:a16="http://schemas.microsoft.com/office/drawing/2014/main" id="{5D1832FB-2023-4B07-CC24-C869E3549FF7}"/>
+              </a:ext>
+            </a:extLst>
+          </p:cNvPr>
+          <p:cNvPicPr>
+            <a:picLocks noChangeAspect="1"/>
+          </p:cNvPicPr>
+          <p:nvPr/>
+        </p:nvPicPr>
+        <p:blipFill>
+          <a:blip r:embed="rId2"/>
+          <a:stretch>
+            <a:fillRect/>
+          </a:stretch>
+        </p:blipFill>
+        <p:spPr>
+          <a:xfrm>
+            <a:off x="2209800" y="380427"/>
+            <a:ext cx="7772400" cy="6097145"/>
+          </a:xfrm>
+          <a:prstGeom prst="rect">
+            <a:avLst/>
+          </a:prstGeom>
+        </p:spPr>
+      </p:pic>
+      <p:sp>
+        <p:nvSpPr>
+          <p:cNvPr id="3" name="Textfeld 2">
+            <a:extLst>
+              <a:ext uri="{FF2B5EF4-FFF2-40B4-BE49-F238E27FC236}">
+                <a16:creationId xmlns:a16="http://schemas.microsoft.com/office/drawing/2014/main" id="{C5F579F0-6784-06DB-72AC-28006FD50AB6}"/>
+              </a:ext>
+            </a:extLst>
+          </p:cNvPr>
+          <p:cNvSpPr txBox="1"/>
+          <p:nvPr/>
+        </p:nvSpPr>
+        <p:spPr>
+          <a:xfrm>
+            <a:off x="0" y="30191"/>
+            <a:ext cx="2549159" cy="369332"/>
+          </a:xfrm>
+          <a:prstGeom prst="rect">
+            <a:avLst/>
+          </a:prstGeom>
+          <a:noFill/>
+        </p:spPr>
+        <p:txBody>
+          <a:bodyPr wrap="none" rtlCol="0">
+            <a:spAutoFit/>
+          </a:bodyPr>
+          <a:lstStyle/>
+          <a:p>
+            <a:r>
+              <a:rPr lang="de-DE" dirty="0"/>
+              <a:t>Startseite Administrator</a:t>
+            </a:r>
+          </a:p>
+        </p:txBody>
+      </p:sp>
+    </p:spTree>
+    <p:extLst>
+      <p:ext uri="{BB962C8B-B14F-4D97-AF65-F5344CB8AC3E}">
+        <p14:creationId xmlns:p14="http://schemas.microsoft.com/office/powerpoint/2010/main" val="3858987188"/>
+      </p:ext>
+    </p:extLst>
+  </p:cSld>
+  <p:clrMapOvr>
+    <a:masterClrMapping/>
+  </p:clrMapOvr>
+</p:sld>
+</file>
+
+<file path=ppt/slides/slide3.xml><?xml version="1.0" encoding="utf-8"?>
+<p:sld xmlns:a="http://schemas.openxmlformats.org/drawingml/2006/main" xmlns:r="http://schemas.openxmlformats.org/officeDocument/2006/relationships" xmlns:p="http://schemas.openxmlformats.org/presentationml/2006/main">
+  <p:cSld>
+    <p:spTree>
+      <p:nvGrpSpPr>
+        <p:cNvPr id="1" name=""/>
+        <p:cNvGrpSpPr/>
+        <p:nvPr/>
+      </p:nvGrpSpPr>
+      <p:grpSpPr>
+        <a:xfrm>
+          <a:off x="0" y="0"/>
+          <a:ext cx="0" cy="0"/>
+          <a:chOff x="0" y="0"/>
+          <a:chExt cx="0" cy="0"/>
+        </a:xfrm>
+      </p:grpSpPr>
+      <p:pic>
+        <p:nvPicPr>
+          <p:cNvPr id="2" name="Grafik 1">
+            <a:extLst>
+              <a:ext uri="{FF2B5EF4-FFF2-40B4-BE49-F238E27FC236}">
+                <a16:creationId xmlns:a16="http://schemas.microsoft.com/office/drawing/2014/main" id="{7EC097E0-187E-2098-354A-60148E99BB3B}"/>
+              </a:ext>
+            </a:extLst>
+          </p:cNvPr>
+          <p:cNvPicPr>
+            <a:picLocks noChangeAspect="1"/>
+          </p:cNvPicPr>
+          <p:nvPr/>
+        </p:nvPicPr>
+        <p:blipFill>
+          <a:blip r:embed="rId2"/>
+          <a:stretch>
+            <a:fillRect/>
+          </a:stretch>
+        </p:blipFill>
+        <p:spPr>
+          <a:xfrm>
+            <a:off x="2209800" y="286749"/>
+            <a:ext cx="7772400" cy="6284501"/>
+          </a:xfrm>
+          <a:prstGeom prst="rect">
+            <a:avLst/>
+          </a:prstGeom>
+        </p:spPr>
+      </p:pic>
+      <p:sp>
+        <p:nvSpPr>
+          <p:cNvPr id="3" name="Textfeld 2">
+            <a:extLst>
+              <a:ext uri="{FF2B5EF4-FFF2-40B4-BE49-F238E27FC236}">
+                <a16:creationId xmlns:a16="http://schemas.microsoft.com/office/drawing/2014/main" id="{7047FA36-3731-EA68-A488-CAC693E3B0A5}"/>
+              </a:ext>
+            </a:extLst>
+          </p:cNvPr>
+          <p:cNvSpPr txBox="1"/>
+          <p:nvPr/>
+        </p:nvSpPr>
+        <p:spPr>
+          <a:xfrm>
+            <a:off x="0" y="30191"/>
+            <a:ext cx="2397066" cy="369332"/>
+          </a:xfrm>
+          <a:prstGeom prst="rect">
+            <a:avLst/>
+          </a:prstGeom>
+          <a:noFill/>
+        </p:spPr>
+        <p:txBody>
+          <a:bodyPr wrap="none" rtlCol="0">
+            <a:spAutoFit/>
+          </a:bodyPr>
+          <a:lstStyle/>
+          <a:p>
+            <a:r>
+              <a:rPr lang="de-DE" dirty="0"/>
+              <a:t>Startseite Projektleiter</a:t>
+            </a:r>
+          </a:p>
+        </p:txBody>
+      </p:sp>
+    </p:spTree>
+    <p:extLst>
+      <p:ext uri="{BB962C8B-B14F-4D97-AF65-F5344CB8AC3E}">
+        <p14:creationId xmlns:p14="http://schemas.microsoft.com/office/powerpoint/2010/main" val="3267517735"/>
+      </p:ext>
+    </p:extLst>
+  </p:cSld>
+  <p:clrMapOvr>
+    <a:masterClrMapping/>
+  </p:clrMapOvr>
+</p:sld>
+</file>
+
+<file path=ppt/slides/slide4.xml><?xml version="1.0" encoding="utf-8"?>
+<p:sld xmlns:a="http://schemas.openxmlformats.org/drawingml/2006/main" xmlns:r="http://schemas.openxmlformats.org/officeDocument/2006/relationships" xmlns:p="http://schemas.openxmlformats.org/presentationml/2006/main">
+  <p:cSld>
+    <p:spTree>
+      <p:nvGrpSpPr>
+        <p:cNvPr id="1" name=""/>
+        <p:cNvGrpSpPr/>
+        <p:nvPr/>
+      </p:nvGrpSpPr>
+      <p:grpSpPr>
+        <a:xfrm>
+          <a:off x="0" y="0"/>
+          <a:ext cx="0" cy="0"/>
+          <a:chOff x="0" y="0"/>
+          <a:chExt cx="0" cy="0"/>
+        </a:xfrm>
+      </p:grpSpPr>
+      <p:pic>
+        <p:nvPicPr>
+          <p:cNvPr id="2" name="Grafik 1">
+            <a:extLst>
+              <a:ext uri="{FF2B5EF4-FFF2-40B4-BE49-F238E27FC236}">
+                <a16:creationId xmlns:a16="http://schemas.microsoft.com/office/drawing/2014/main" id="{42619A76-62A7-2F06-D8AF-2EE9DE915CED}"/>
+              </a:ext>
+            </a:extLst>
+          </p:cNvPr>
+          <p:cNvPicPr>
+            <a:picLocks noChangeAspect="1"/>
+          </p:cNvPicPr>
+          <p:nvPr/>
+        </p:nvPicPr>
+        <p:blipFill>
+          <a:blip r:embed="rId2"/>
+          <a:stretch>
+            <a:fillRect/>
+          </a:stretch>
+        </p:blipFill>
+        <p:spPr>
+          <a:xfrm>
+            <a:off x="2209800" y="439615"/>
+            <a:ext cx="7772400" cy="5978769"/>
+          </a:xfrm>
+          <a:prstGeom prst="rect">
+            <a:avLst/>
+          </a:prstGeom>
+        </p:spPr>
+      </p:pic>
+      <p:sp>
+        <p:nvSpPr>
+          <p:cNvPr id="3" name="Textfeld 2">
+            <a:extLst>
+              <a:ext uri="{FF2B5EF4-FFF2-40B4-BE49-F238E27FC236}">
+                <a16:creationId xmlns:a16="http://schemas.microsoft.com/office/drawing/2014/main" id="{E7E3CA88-095D-7A0B-145A-A1076B924F24}"/>
+              </a:ext>
+            </a:extLst>
+          </p:cNvPr>
+          <p:cNvSpPr txBox="1"/>
+          <p:nvPr/>
+        </p:nvSpPr>
+        <p:spPr>
+          <a:xfrm>
+            <a:off x="0" y="30191"/>
+            <a:ext cx="1386918" cy="646331"/>
+          </a:xfrm>
+          <a:prstGeom prst="rect">
+            <a:avLst/>
+          </a:prstGeom>
+          <a:noFill/>
+        </p:spPr>
+        <p:txBody>
+          <a:bodyPr wrap="none" rtlCol="0">
+            <a:spAutoFit/>
+          </a:bodyPr>
+          <a:lstStyle/>
+          <a:p>
+            <a:r>
+              <a:rPr lang="de-DE" dirty="0"/>
+              <a:t>Projektleiter</a:t>
+            </a:r>
+          </a:p>
+          <a:p>
+            <a:r>
+              <a:rPr lang="de-DE" dirty="0"/>
+              <a:t>Mein Status</a:t>
+            </a:r>
+          </a:p>
+        </p:txBody>
+      </p:sp>
+    </p:spTree>
+    <p:extLst>
+      <p:ext uri="{BB962C8B-B14F-4D97-AF65-F5344CB8AC3E}">
+        <p14:creationId xmlns:p14="http://schemas.microsoft.com/office/powerpoint/2010/main" val="355477721"/>
       </p:ext>
     </p:extLst>
   </p:cSld>

</xml_diff>